<commit_message>
feat(hsk1): rework slide Buổi 02 + Buổi 16, sửa bug teaching-coach, thêm nguyên liệu
- Buổi 02 (Chào hỏi): thêm icon minh hoạ + audio biến điệu/erhua/khinh thanh.
- Buổi 16 (Ôn tập): render lại audio, bỏ ảnh b09 lỗi, thêm slide18/21.
- teaching-coach/build_deck.py: image_w_in cho ảnh nhỏ cạnh bảng dày từ, font
  bảng tự co theo chiều cao hàng, icon người nói 1-codepoint (PowerPoint vỡ
  icon ghép ZWJ), hội thoại >2 người chuyển sang layout kịch bản 1 cột thay
  vì 2 cột trái/phải (phát hiện khi review buổi 02).
- Thêm nguyên liệu: 新HSK1教程3.0.pdf (sách chính, đã dẫn nguồn trong docs),
  bài tập mẫu chủ đề 了+ thời tiết (buổi 12).
</commit_message>
<xml_diff>
--- a/output/hsk1/buoi16_ontap/slide/Buoi-16-Ontap.pptx
+++ b/output/hsk1/buoi16_ontap/slide/Buoi-16-Ontap.pptx
@@ -26,6 +26,7 @@
     <p:sldId id="274" r:id="rId25"/>
     <p:sldId id="275" r:id="rId26"/>
     <p:sldId id="276" r:id="rId27"/>
+    <p:sldId id="277" r:id="rId28"/>
   </p:sldIdLst>
   <p:sldSz cx="12191695" cy="6858000" type="screen4x3"/>
   <p:notesSz cx="6858000" cy="9144000"/>
@@ -3202,7 +3203,7 @@
                 <a:ea typeface="Microsoft YaHei"/>
                 <a:cs typeface="Microsoft YaHei"/>
               </a:rPr>
-              <a:t>Ôn tập tổng hợp 15 bài · New HSK Course 1 (3.0)</a:t>
+              <a:t>Ôn tập tổng hợp · New HSK Course 1 (3.0)</a:t>
             </a:r>
           </a:p>
           <a:p>
@@ -3381,7 +3382,7 @@
                 <a:ea typeface="Microsoft YaHei"/>
                 <a:cs typeface="Microsoft YaHei"/>
               </a:rPr>
-              <a:t>语法 · 第8课</a:t>
+              <a:t>语法 · thời gian</a:t>
             </a:r>
           </a:p>
         </p:txBody>
@@ -3417,7 +3418,7 @@
                 <a:ea typeface="Microsoft YaHei"/>
                 <a:cs typeface="Microsoft YaHei"/>
               </a:rPr>
-              <a:t>方位词 · 介词在 · 能愿动词 能</a:t>
+              <a:t>时间的表达 · 状语顺序</a:t>
             </a:r>
           </a:p>
         </p:txBody>
@@ -3453,7 +3454,7 @@
                 <a:ea typeface="Microsoft YaHei"/>
                 <a:cs typeface="Microsoft YaHei"/>
               </a:rPr>
-              <a:t>方位词: 上/下/里/外/前/后</a:t>
+              <a:t>点/分: giờ cụ thể; 上午/下午/晚上: khoảng thời gian</a:t>
             </a:r>
           </a:p>
           <a:p>
@@ -3471,25 +3472,7 @@
                 <a:ea typeface="Microsoft YaHei"/>
                 <a:cs typeface="Microsoft YaHei"/>
               </a:rPr>
-              <a:t>在 + nơi chốn đứng TRƯỚC động từ (giới từ chỉ nơi diễn ra hành động)</a:t>
-            </a:r>
-          </a:p>
-          <a:p>
-            <a:pPr>
-              <a:spcBef>
-                <a:spcPts val="400"/>
-              </a:spcBef>
-            </a:pPr>
-            <a:r>
-              <a:rPr sz="2000" b="1" i="0">
-                <a:solidFill>
-                  <a:srgbClr val="1F2933"/>
-                </a:solidFill>
-                <a:latin typeface="Calibri"/>
-                <a:ea typeface="Microsoft YaHei"/>
-                <a:cs typeface="Microsoft YaHei"/>
-              </a:rPr>
-              <a:t>能: có thể (năng lực/điều kiện khách quan)</a:t>
+              <a:t>Khi cùng làm trạng ngữ: THỜI GIAN luôn đứng trước NƠI CHỐN</a:t>
             </a:r>
           </a:p>
           <a:p>
@@ -3507,7 +3490,7 @@
                 <a:ea typeface="Microsoft YaHei"/>
                 <a:cs typeface="Microsoft YaHei"/>
               </a:rPr>
-              <a:t>猫在桌子下。</a:t>
+              <a:t>现在三点半，我们六点见吧。</a:t>
             </a:r>
             <a:r>
               <a:rPr sz="1500" b="0" i="1">
@@ -3518,7 +3501,7 @@
                 <a:ea typeface="Microsoft YaHei"/>
                 <a:cs typeface="Microsoft YaHei"/>
               </a:rPr>
-              <a:t>  Māo zài zhuōzi xià.</a:t>
+              <a:t>  Xiànzài sān diǎn bàn, wǒmen liù diǎn jiàn ba.</a:t>
             </a:r>
           </a:p>
           <a:p>
@@ -3536,7 +3519,7 @@
                 <a:ea typeface="Microsoft YaHei"/>
                 <a:cs typeface="Microsoft YaHei"/>
               </a:rPr>
-              <a:t>Con mèo ở dưới bàn.</a:t>
+              <a:t>Bây giờ 3 rưỡi, 6 giờ mình gặp nhau nhé.</a:t>
             </a:r>
           </a:p>
           <a:p>
@@ -3554,7 +3537,7 @@
                 <a:ea typeface="Microsoft YaHei"/>
                 <a:cs typeface="Microsoft YaHei"/>
               </a:rPr>
-              <a:t>我爸爸在医院工作。</a:t>
+              <a:t>我明天上午在学校学习。</a:t>
             </a:r>
             <a:r>
               <a:rPr sz="1500" b="0" i="1">
@@ -3565,7 +3548,7 @@
                 <a:ea typeface="Microsoft YaHei"/>
                 <a:cs typeface="Microsoft YaHei"/>
               </a:rPr>
-              <a:t>  Wǒ bàba zài yīyuàn gōngzuò.</a:t>
+              <a:t>  Wǒ míngtiān shàngwǔ zài xuéxiào xuéxí.</a:t>
             </a:r>
           </a:p>
           <a:p>
@@ -3583,54 +3566,7 @@
                 <a:ea typeface="Microsoft YaHei"/>
                 <a:cs typeface="Microsoft YaHei"/>
               </a:rPr>
-              <a:t>Bố mình làm việc ở bệnh viện.</a:t>
-            </a:r>
-          </a:p>
-          <a:p>
-            <a:pPr>
-              <a:spcBef>
-                <a:spcPts val="2000"/>
-              </a:spcBef>
-            </a:pPr>
-            <a:r>
-              <a:rPr sz="2600" b="1" i="0">
-                <a:solidFill>
-                  <a:srgbClr val="1F2933"/>
-                </a:solidFill>
-                <a:latin typeface="Calibri"/>
-                <a:ea typeface="Microsoft YaHei"/>
-                <a:cs typeface="Microsoft YaHei"/>
-              </a:rPr>
-              <a:t>你能来吗？</a:t>
-            </a:r>
-            <a:r>
-              <a:rPr sz="1500" b="0" i="1">
-                <a:solidFill>
-                  <a:srgbClr val="8E2B20"/>
-                </a:solidFill>
-                <a:latin typeface="Calibri"/>
-                <a:ea typeface="Microsoft YaHei"/>
-                <a:cs typeface="Microsoft YaHei"/>
-              </a:rPr>
-              <a:t>  Nǐ néng lái ma?</a:t>
-            </a:r>
-          </a:p>
-          <a:p>
-            <a:pPr>
-              <a:spcBef>
-                <a:spcPts val="300"/>
-              </a:spcBef>
-            </a:pPr>
-            <a:r>
-              <a:rPr sz="1500" b="0" i="0">
-                <a:solidFill>
-                  <a:srgbClr val="6B7683"/>
-                </a:solidFill>
-                <a:latin typeface="Calibri"/>
-                <a:ea typeface="Microsoft YaHei"/>
-                <a:cs typeface="Microsoft YaHei"/>
-              </a:rPr>
-              <a:t>Bạn có thể đến được không?</a:t>
+              <a:t>Sáng mai mình học ở trường.</a:t>
             </a:r>
           </a:p>
           <a:p>
@@ -3648,7 +3584,7 @@
                 <a:ea typeface="Microsoft YaHei"/>
                 <a:cs typeface="Microsoft YaHei"/>
               </a:rPr>
-              <a:t>• 在 ở đây là GIỚI TỪ (trước động từ) — khác 在 phó từ chỉ đang diễn ra (第11课), cùng chữ 2 vai trò.</a:t>
+              <a:t>• 明天(thời gian) đứng TRƯỚC 在学校(nơi chốn) trong câu ví dụ trên.</a:t>
             </a:r>
           </a:p>
           <a:p>
@@ -3677,14 +3613,14 @@
                 <a:ea typeface="Microsoft YaHei"/>
                 <a:cs typeface="Microsoft YaHei"/>
               </a:rPr>
-              <a:t>能 = điều kiện khách quan; 会 = kỹ năng học được — đừng nhầm.</a:t>
+              <a:t>Từ chỉ thời gian LUÔN đứng trước động từ, giống mọi trạng ngữ khác.</a:t>
             </a:r>
           </a:p>
         </p:txBody>
       </p:sp>
       <p:pic>
         <p:nvPicPr>
-          <p:cNvPr id="7" name="Picture 6" descr="b08_fangwei_zai_neng.jpg"/>
+          <p:cNvPr id="7" name="Picture 6" descr="b07_dian_fen_ba.jpg"/>
           <p:cNvPicPr>
             <a:picLocks noChangeAspect="1"/>
           </p:cNvPicPr>
@@ -3698,8 +3634,8 @@
         </p:blipFill>
         <p:spPr>
           <a:xfrm>
-            <a:off x="7345375" y="2553525"/>
-            <a:ext cx="4297680" cy="2866518"/>
+            <a:off x="7820649" y="1481328"/>
+            <a:ext cx="3347132" cy="5010912"/>
           </a:xfrm>
           <a:prstGeom prst="rect">
             <a:avLst/>
@@ -3920,7 +3856,7 @@
                 <a:ea typeface="Microsoft YaHei"/>
                 <a:cs typeface="Microsoft YaHei"/>
               </a:rPr>
-              <a:t>语法 · 第9课</a:t>
+              <a:t>语法 · câu hỏi</a:t>
             </a:r>
           </a:p>
         </p:txBody>
@@ -3956,7 +3892,7 @@
                 <a:ea typeface="Microsoft YaHei"/>
                 <a:cs typeface="Microsoft YaHei"/>
               </a:rPr>
-              <a:t>存现句 · 第 · 时间+处所</a:t>
+              <a:t>7 cách đặt câu hỏi</a:t>
             </a:r>
           </a:p>
         </p:txBody>
@@ -3970,7 +3906,7 @@
         <p:spPr>
           <a:xfrm>
             <a:off x="548640" y="1481328"/>
-            <a:ext cx="6430975" cy="5010912"/>
+            <a:ext cx="11094415" cy="5010912"/>
           </a:xfrm>
           <a:prstGeom prst="rect">
             <a:avLst/>
@@ -3992,7 +3928,7 @@
                 <a:ea typeface="Microsoft YaHei"/>
                 <a:cs typeface="Microsoft YaHei"/>
               </a:rPr>
-              <a:t>存现句: biểu thị có ai/cái gì tồn tại ở một nơi</a:t>
+              <a:t>吗: câu hỏi có/không</a:t>
             </a:r>
           </a:p>
           <a:p>
@@ -4010,7 +3946,7 @@
                 <a:ea typeface="Microsoft YaHei"/>
                 <a:cs typeface="Microsoft YaHei"/>
               </a:rPr>
-              <a:t>第+số từ: số thứ tự</a:t>
+              <a:t>怎么: hỏi CÁCH THỨC · 怎么样: hỏi Ý KIẾN/TÌNH TRẠNG</a:t>
             </a:r>
           </a:p>
           <a:p>
@@ -4028,7 +3964,7 @@
                 <a:ea typeface="Microsoft YaHei"/>
                 <a:cs typeface="Microsoft YaHei"/>
               </a:rPr>
-              <a:t>Khi cùng làm trạng ngữ: THỜI GIAN luôn đứng trước NƠI CHỐN</a:t>
+              <a:t>正反问: V不V / A不A</a:t>
             </a:r>
           </a:p>
           <a:p>
@@ -4046,7 +3982,7 @@
                 <a:ea typeface="Microsoft YaHei"/>
                 <a:cs typeface="Microsoft YaHei"/>
               </a:rPr>
-              <a:t>前边有一只狗。</a:t>
+              <a:t>你是法国人吗？</a:t>
             </a:r>
             <a:r>
               <a:rPr sz="1500" b="0" i="1">
@@ -4057,7 +3993,7 @@
                 <a:ea typeface="Microsoft YaHei"/>
                 <a:cs typeface="Microsoft YaHei"/>
               </a:rPr>
-              <a:t>  Qiánbian yǒu yì zhī gǒu.</a:t>
+              <a:t>  Nǐ shì Fǎguó rén ma?</a:t>
             </a:r>
           </a:p>
           <a:p>
@@ -4075,7 +4011,7 @@
                 <a:ea typeface="Microsoft YaHei"/>
                 <a:cs typeface="Microsoft YaHei"/>
               </a:rPr>
-              <a:t>Đằng trước có một con chó.</a:t>
+              <a:t>Bạn là người Pháp phải không?</a:t>
             </a:r>
           </a:p>
           <a:p>
@@ -4093,7 +4029,7 @@
                 <a:ea typeface="Microsoft YaHei"/>
                 <a:cs typeface="Microsoft YaHei"/>
               </a:rPr>
-              <a:t>我明天上午在学校学习。</a:t>
+              <a:t>这个怎么样？</a:t>
             </a:r>
             <a:r>
               <a:rPr sz="1500" b="0" i="1">
@@ -4104,7 +4040,7 @@
                 <a:ea typeface="Microsoft YaHei"/>
                 <a:cs typeface="Microsoft YaHei"/>
               </a:rPr>
-              <a:t>  Wǒ míngtiān shàngwǔ zài xuéxiào xuéxí.</a:t>
+              <a:t>  Zhège zěnmeyàng?</a:t>
             </a:r>
           </a:p>
           <a:p>
@@ -4122,7 +4058,54 @@
                 <a:ea typeface="Microsoft YaHei"/>
                 <a:cs typeface="Microsoft YaHei"/>
               </a:rPr>
-              <a:t>Sáng mai mình học ở trường.</a:t>
+              <a:t>Cái này thế nào?</a:t>
+            </a:r>
+          </a:p>
+          <a:p>
+            <a:pPr>
+              <a:spcBef>
+                <a:spcPts val="2000"/>
+              </a:spcBef>
+            </a:pPr>
+            <a:r>
+              <a:rPr sz="2600" b="1" i="0">
+                <a:solidFill>
+                  <a:srgbClr val="1F2933"/>
+                </a:solidFill>
+                <a:latin typeface="Calibri"/>
+                <a:ea typeface="Microsoft YaHei"/>
+                <a:cs typeface="Microsoft YaHei"/>
+              </a:rPr>
+              <a:t>你去不去？</a:t>
+            </a:r>
+            <a:r>
+              <a:rPr sz="1500" b="0" i="1">
+                <a:solidFill>
+                  <a:srgbClr val="8E2B20"/>
+                </a:solidFill>
+                <a:latin typeface="Calibri"/>
+                <a:ea typeface="Microsoft YaHei"/>
+                <a:cs typeface="Microsoft YaHei"/>
+              </a:rPr>
+              <a:t>  Nǐ qù bu qù?</a:t>
+            </a:r>
+          </a:p>
+          <a:p>
+            <a:pPr>
+              <a:spcBef>
+                <a:spcPts val="300"/>
+              </a:spcBef>
+            </a:pPr>
+            <a:r>
+              <a:rPr sz="1500" b="0" i="0">
+                <a:solidFill>
+                  <a:srgbClr val="6B7683"/>
+                </a:solidFill>
+                <a:latin typeface="Calibri"/>
+                <a:ea typeface="Microsoft YaHei"/>
+                <a:cs typeface="Microsoft YaHei"/>
+              </a:rPr>
+              <a:t>Bạn có đi không?</a:t>
             </a:r>
           </a:p>
           <a:p>
@@ -4140,7 +4123,7 @@
                 <a:ea typeface="Microsoft YaHei"/>
                 <a:cs typeface="Microsoft YaHei"/>
               </a:rPr>
-              <a:t>• 明天(thời gian) đứng TRƯỚC 在学校(nơi chốn) trong câu ví dụ trên.</a:t>
+              <a:t>• Còn 什么(gì)·谁(ai)·哪(nào)·几/多少(bao nhiêu)·呢(…thì sao?) — đủ 7 cách hỏi cơ bản của HSK1.</a:t>
             </a:r>
           </a:p>
           <a:p>
@@ -4169,54 +4152,30 @@
                 <a:ea typeface="Microsoft YaHei"/>
                 <a:cs typeface="Microsoft YaHei"/>
               </a:rPr>
-              <a:t>存现句 phủ định KHÔNG dùng số từ + lượng từ trước tân ngữ.</a:t>
+              <a:t>怎么 hỏi CÁCH THỨC, 怎么样 hỏi Ý KIẾN/TÌNH TRẠNG — dễ nhầm nhất.</a:t>
             </a:r>
           </a:p>
         </p:txBody>
       </p:sp>
       <p:pic>
         <p:nvPicPr>
-          <p:cNvPr id="7" name="Picture 6" descr="b09_cunxian_di.jpg"/>
-          <p:cNvPicPr>
-            <a:picLocks noChangeAspect="1"/>
-          </p:cNvPicPr>
-          <p:nvPr/>
-        </p:nvPicPr>
-        <p:blipFill>
-          <a:blip r:embed="rId2"/>
-          <a:stretch>
-            <a:fillRect/>
-          </a:stretch>
-        </p:blipFill>
-        <p:spPr>
-          <a:xfrm>
-            <a:off x="7345375" y="2553525"/>
-            <a:ext cx="4297680" cy="2866518"/>
-          </a:xfrm>
-          <a:prstGeom prst="rect">
-            <a:avLst/>
-          </a:prstGeom>
-        </p:spPr>
-      </p:pic>
-      <p:pic>
-        <p:nvPicPr>
-          <p:cNvPr id="8" name="slide11.mp3">
+          <p:cNvPr id="7" name="slide11.mp3">
             <a:hlinkClick r:id="" action="ppaction://media"/>
           </p:cNvPr>
           <p:cNvPicPr>
             <a:picLocks noChangeAspect="1"/>
           </p:cNvPicPr>
           <p:nvPr>
-            <a:videoFile r:link="rId4"/>
+            <a:videoFile r:link="rId3"/>
             <p:extLst>
               <p:ext uri="{DAA4B4D4-6D71-4841-9C94-3DE7FCFB9230}">
-                <p14:media xmlns:p14="http://schemas.microsoft.com/office/powerpoint/2010/main" r:embed="rId3"/>
+                <p14:media xmlns:p14="http://schemas.microsoft.com/office/powerpoint/2010/main" r:embed="rId2"/>
               </p:ext>
             </p:extLst>
           </p:nvPr>
         </p:nvPicPr>
         <p:blipFill>
-          <a:blip r:embed="rId5"/>
+          <a:blip r:embed="rId4"/>
           <a:stretch>
             <a:fillRect/>
           </a:stretch>
@@ -4252,7 +4211,7 @@
                   </p:stCondLst>
                 </p:cTn>
                 <p:tgtEl>
-                  <p:spTgt spid="8"/>
+                  <p:spTgt spid="7"/>
                 </p:tgtEl>
               </p:cMediaNode>
             </p:video>
@@ -4412,7 +4371,7 @@
                 <a:ea typeface="Microsoft YaHei"/>
                 <a:cs typeface="Microsoft YaHei"/>
               </a:rPr>
-              <a:t>语法 · 第10课</a:t>
+              <a:t>语法 · 能愿动词</a:t>
             </a:r>
           </a:p>
         </p:txBody>
@@ -4448,7 +4407,7 @@
                 <a:ea typeface="Microsoft YaHei"/>
                 <a:cs typeface="Microsoft YaHei"/>
               </a:rPr>
-              <a:t>形容词谓语句 · 钱数 · 怎么样</a:t>
+              <a:t>能愿动词：会 · 想 · 能 · 要 · 可以</a:t>
             </a:r>
           </a:p>
         </p:txBody>
@@ -4484,7 +4443,7 @@
                 <a:ea typeface="Microsoft YaHei"/>
                 <a:cs typeface="Microsoft YaHei"/>
               </a:rPr>
-              <a:t>Tính từ làm vị ngữ trực tiếp (không cần 是), thường có 很/真</a:t>
+              <a:t>会 = biết (kỹ năng học được) · 想 = muốn, dự định · 能 = có thể (điều kiện/khả năng)</a:t>
             </a:r>
           </a:p>
           <a:p>
@@ -4502,7 +4461,7 @@
                 <a:ea typeface="Microsoft YaHei"/>
                 <a:cs typeface="Microsoft YaHei"/>
               </a:rPr>
-              <a:t>钱数: 元/块 — 角/毛 — 分</a:t>
+              <a:t>要 = muốn/định làm · 可以 = được phép/có thể</a:t>
             </a:r>
           </a:p>
           <a:p>
@@ -4520,7 +4479,7 @@
                 <a:ea typeface="Microsoft YaHei"/>
                 <a:cs typeface="Microsoft YaHei"/>
               </a:rPr>
-              <a:t>怎么样: hỏi ý kiến/tình trạng</a:t>
+              <a:t>Cấu trúc chung: 能愿动词 + Động từ chính — LUÔN đứng trước động từ</a:t>
             </a:r>
           </a:p>
           <a:p>
@@ -4538,7 +4497,7 @@
                 <a:ea typeface="Microsoft YaHei"/>
                 <a:cs typeface="Microsoft YaHei"/>
               </a:rPr>
-              <a:t>这儿的苹果真便宜！</a:t>
+              <a:t>我会说汉语，也能来。</a:t>
             </a:r>
             <a:r>
               <a:rPr sz="1500" b="0" i="1">
@@ -4549,7 +4508,7 @@
                 <a:ea typeface="Microsoft YaHei"/>
                 <a:cs typeface="Microsoft YaHei"/>
               </a:rPr>
-              <a:t>  Zhèr de píngguǒ zhēn piányi!</a:t>
+              <a:t>  Wǒ huì shuō Hànyǔ, yě néng lái.</a:t>
             </a:r>
           </a:p>
           <a:p>
@@ -4567,7 +4526,7 @@
                 <a:ea typeface="Microsoft YaHei"/>
                 <a:cs typeface="Microsoft YaHei"/>
               </a:rPr>
-              <a:t>Táo ở đây rẻ thật!</a:t>
+              <a:t>Mình biết nói tiếng Trung, cũng đến được.</a:t>
             </a:r>
           </a:p>
           <a:p>
@@ -4585,7 +4544,7 @@
                 <a:ea typeface="Microsoft YaHei"/>
                 <a:cs typeface="Microsoft YaHei"/>
               </a:rPr>
-              <a:t>这件衣服三十五块。</a:t>
+              <a:t>我想喝茶，可以吗？</a:t>
             </a:r>
             <a:r>
               <a:rPr sz="1500" b="0" i="1">
@@ -4596,7 +4555,7 @@
                 <a:ea typeface="Microsoft YaHei"/>
                 <a:cs typeface="Microsoft YaHei"/>
               </a:rPr>
-              <a:t>  Zhè jiàn yīfu sānshíwǔ kuài.</a:t>
+              <a:t>  Wǒ xiǎng hē chá, kěyǐ ma?</a:t>
             </a:r>
           </a:p>
           <a:p>
@@ -4614,7 +4573,7 @@
                 <a:ea typeface="Microsoft YaHei"/>
                 <a:cs typeface="Microsoft YaHei"/>
               </a:rPr>
-              <a:t>Cái áo này 35 tệ.</a:t>
+              <a:t>Mình muốn uống trà, được không?</a:t>
             </a:r>
           </a:p>
           <a:p>
@@ -4632,7 +4591,7 @@
                 <a:ea typeface="Microsoft YaHei"/>
                 <a:cs typeface="Microsoft YaHei"/>
               </a:rPr>
-              <a:t>这个怎么样？</a:t>
+              <a:t>我要学中文。</a:t>
             </a:r>
             <a:r>
               <a:rPr sz="1500" b="0" i="1">
@@ -4643,7 +4602,7 @@
                 <a:ea typeface="Microsoft YaHei"/>
                 <a:cs typeface="Microsoft YaHei"/>
               </a:rPr>
-              <a:t>  Zhège zěnmeyàng?</a:t>
+              <a:t>  Wǒ yào xué Zhōngwén.</a:t>
             </a:r>
           </a:p>
           <a:p>
@@ -4661,7 +4620,7 @@
                 <a:ea typeface="Microsoft YaHei"/>
                 <a:cs typeface="Microsoft YaHei"/>
               </a:rPr>
-              <a:t>Cái này thế nào?</a:t>
+              <a:t>Mình định học tiếng Trung.</a:t>
             </a:r>
           </a:p>
           <a:p>
@@ -4679,7 +4638,7 @@
                 <a:ea typeface="Microsoft YaHei"/>
                 <a:cs typeface="Microsoft YaHei"/>
               </a:rPr>
-              <a:t>• 元 (viết) = 块 (nói) — cùng nghĩa, khác văn phong.</a:t>
+              <a:t>• Phủ định: thêm 不 trước — 不会·不想·不能·不可以 (riêng 要 phủ định 'đừng' dùng 不要/别).</a:t>
             </a:r>
           </a:p>
           <a:p>
@@ -4708,14 +4667,14 @@
                 <a:ea typeface="Microsoft YaHei"/>
                 <a:cs typeface="Microsoft YaHei"/>
               </a:rPr>
-              <a:t>SAI 我是好 ❌ → ĐÚNG 我很好 ✔ — tính từ vị ngữ không đi với 是.</a:t>
+              <a:t>Dễ lẫn nhất: 会 = kỹ năng học được, 能 = điều kiện khách quan, 想/要 = ý muốn, 可以 = được phép.</a:t>
             </a:r>
           </a:p>
         </p:txBody>
       </p:sp>
       <p:pic>
         <p:nvPicPr>
-          <p:cNvPr id="7" name="Picture 6" descr="b10_adj_pred_qian.jpg"/>
+          <p:cNvPr id="7" name="Picture 6" descr="b13_keyi_yixia.jpg"/>
           <p:cNvPicPr>
             <a:picLocks noChangeAspect="1"/>
           </p:cNvPicPr>
@@ -4729,8 +4688,8 @@
         </p:blipFill>
         <p:spPr>
           <a:xfrm>
-            <a:off x="7615123" y="1481328"/>
-            <a:ext cx="3758184" cy="5010912"/>
+            <a:off x="7345375" y="2554224"/>
+            <a:ext cx="4297680" cy="2865120"/>
           </a:xfrm>
           <a:prstGeom prst="rect">
             <a:avLst/>
@@ -4951,7 +4910,7 @@
                 <a:ea typeface="Microsoft YaHei"/>
                 <a:cs typeface="Microsoft YaHei"/>
               </a:rPr>
-              <a:t>语法 · 第11课</a:t>
+              <a:t>语法 · nhiều động từ/tân ngữ</a:t>
             </a:r>
           </a:p>
         </p:txBody>
@@ -4987,7 +4946,7 @@
                 <a:ea typeface="Microsoft YaHei"/>
                 <a:cs typeface="Microsoft YaHei"/>
               </a:rPr>
-              <a:t>正反问 · (正)在 · 能愿动词 要</a:t>
+              <a:t>连动句 · 动词+一下 · 双宾语句</a:t>
             </a:r>
           </a:p>
         </p:txBody>
@@ -5023,7 +4982,7 @@
                 <a:ea typeface="Microsoft YaHei"/>
                 <a:cs typeface="Microsoft YaHei"/>
               </a:rPr>
-              <a:t>正反问: V不V / A不A</a:t>
+              <a:t>连动句: 2 cụm động từ nối tiếp, cùng chủ ngữ, đúng trình tự hành động</a:t>
             </a:r>
           </a:p>
           <a:p>
@@ -5041,7 +5000,7 @@
                 <a:ea typeface="Microsoft YaHei"/>
                 <a:cs typeface="Microsoft YaHei"/>
               </a:rPr>
-              <a:t>(正)在 + V (+呢): đang làm gì</a:t>
+              <a:t>动词 + 一下: làm thử/một lần, lịch sự hơn</a:t>
             </a:r>
           </a:p>
           <a:p>
@@ -5059,7 +5018,7 @@
                 <a:ea typeface="Microsoft YaHei"/>
                 <a:cs typeface="Microsoft YaHei"/>
               </a:rPr>
-              <a:t>要: muốn làm, định làm</a:t>
+              <a:t>双宾语句: 1 động từ + 2 tân ngữ (给/问)</a:t>
             </a:r>
           </a:p>
           <a:p>
@@ -5077,7 +5036,7 @@
                 <a:ea typeface="Microsoft YaHei"/>
                 <a:cs typeface="Microsoft YaHei"/>
               </a:rPr>
-              <a:t>你去不去？</a:t>
+              <a:t>我想去超市买东西。</a:t>
             </a:r>
             <a:r>
               <a:rPr sz="1500" b="0" i="1">
@@ -5088,7 +5047,7 @@
                 <a:ea typeface="Microsoft YaHei"/>
                 <a:cs typeface="Microsoft YaHei"/>
               </a:rPr>
-              <a:t>  Nǐ qù bu qù?</a:t>
+              <a:t>  Wǒ xiǎng qù chāoshì mǎi dōngxi.</a:t>
             </a:r>
           </a:p>
           <a:p>
@@ -5106,7 +5065,7 @@
                 <a:ea typeface="Microsoft YaHei"/>
                 <a:cs typeface="Microsoft YaHei"/>
               </a:rPr>
-              <a:t>Bạn có đi không?</a:t>
+              <a:t>Mình muốn đi siêu thị mua đồ.</a:t>
             </a:r>
           </a:p>
           <a:p>
@@ -5124,7 +5083,7 @@
                 <a:ea typeface="Microsoft YaHei"/>
                 <a:cs typeface="Microsoft YaHei"/>
               </a:rPr>
-              <a:t>他正在看电视呢。</a:t>
+              <a:t>我可以看一下吗？</a:t>
             </a:r>
             <a:r>
               <a:rPr sz="1500" b="0" i="1">
@@ -5135,7 +5094,7 @@
                 <a:ea typeface="Microsoft YaHei"/>
                 <a:cs typeface="Microsoft YaHei"/>
               </a:rPr>
-              <a:t>  Tā zhèngzài kàn diànshì ne.</a:t>
+              <a:t>  Wǒ kěyǐ kàn yíxià ma?</a:t>
             </a:r>
           </a:p>
           <a:p>
@@ -5153,7 +5112,7 @@
                 <a:ea typeface="Microsoft YaHei"/>
                 <a:cs typeface="Microsoft YaHei"/>
               </a:rPr>
-              <a:t>Anh ấy đang xem tivi.</a:t>
+              <a:t>Mình xem thử một chút được không?</a:t>
             </a:r>
           </a:p>
           <a:p>
@@ -5171,7 +5130,7 @@
                 <a:ea typeface="Microsoft YaHei"/>
                 <a:cs typeface="Microsoft YaHei"/>
               </a:rPr>
-              <a:t>我要学中文。</a:t>
+              <a:t>请给我一杯茶。</a:t>
             </a:r>
             <a:r>
               <a:rPr sz="1500" b="0" i="1">
@@ -5182,7 +5141,7 @@
                 <a:ea typeface="Microsoft YaHei"/>
                 <a:cs typeface="Microsoft YaHei"/>
               </a:rPr>
-              <a:t>  Wǒ yào xué Zhōngwén.</a:t>
+              <a:t>  Qǐng gěi wǒ yì bēi chá.</a:t>
             </a:r>
           </a:p>
           <a:p>
@@ -5200,7 +5159,7 @@
                 <a:ea typeface="Microsoft YaHei"/>
                 <a:cs typeface="Microsoft YaHei"/>
               </a:rPr>
-              <a:t>Mình định học tiếng Trung.</a:t>
+              <a:t>Cho tôi một cốc trà.</a:t>
             </a:r>
           </a:p>
           <a:p>
@@ -5218,7 +5177,7 @@
                 <a:ea typeface="Microsoft YaHei"/>
                 <a:cs typeface="Microsoft YaHei"/>
               </a:rPr>
-              <a:t>• 正反问 với tính từ cũng dùng 不: 忙不忙？</a:t>
+              <a:t>• 连动句: động từ 1 (đi) trước động từ 2 (mua) — đúng thứ tự làm thật.</a:t>
             </a:r>
           </a:p>
           <a:p>
@@ -5247,14 +5206,14 @@
                 <a:ea typeface="Microsoft YaHei"/>
                 <a:cs typeface="Microsoft YaHei"/>
               </a:rPr>
-              <a:t>Phủ định 'đang làm': 没(有) + V — KHÔNG dùng 不.</a:t>
+              <a:t>双宾语句: 给 + người nhận + vật (给我一杯茶 = cho TÔI một cốc TRÀ).</a:t>
             </a:r>
           </a:p>
         </p:txBody>
       </p:sp>
       <p:pic>
         <p:nvPicPr>
-          <p:cNvPr id="7" name="Picture 6" descr="b11_zhengfan_zai.jpg"/>
+          <p:cNvPr id="7" name="Picture 6" descr="b06_xiang_liandong.jpg"/>
           <p:cNvPicPr>
             <a:picLocks noChangeAspect="1"/>
           </p:cNvPicPr>
@@ -5490,7 +5449,7 @@
                 <a:ea typeface="Microsoft YaHei"/>
                 <a:cs typeface="Microsoft YaHei"/>
               </a:rPr>
-              <a:t>语法 · 第12课</a:t>
+              <a:t>语法 · 了</a:t>
             </a:r>
           </a:p>
         </p:txBody>
@@ -5526,7 +5485,7 @@
                 <a:ea typeface="Microsoft YaHei"/>
                 <a:cs typeface="Microsoft YaHei"/>
               </a:rPr>
-              <a:t>非主谓句 · 了(1) · 太…了</a:t>
+              <a:t>了(1) 变化 · 了(2) 完成 · 非主谓句</a:t>
             </a:r>
           </a:p>
         </p:txBody>
@@ -5562,7 +5521,7 @@
                 <a:ea typeface="Microsoft YaHei"/>
                 <a:cs typeface="Microsoft YaHei"/>
               </a:rPr>
-              <a:t>非主谓句: câu không phân chủ-vị, hay dùng trong khẩu ngữ</a:t>
+              <a:t>了(1) cuối câu: tình huống MỚI / thay đổi</a:t>
             </a:r>
           </a:p>
           <a:p>
@@ -5580,7 +5539,7 @@
                 <a:ea typeface="Microsoft YaHei"/>
                 <a:cs typeface="Microsoft YaHei"/>
               </a:rPr>
-              <a:t>了(1) cuối câu: tình huống MỚI / thay đổi</a:t>
+              <a:t>了(2) ngay sau động từ: hành động ĐÃ hoàn thành</a:t>
             </a:r>
           </a:p>
           <a:p>
@@ -5598,7 +5557,7 @@
                 <a:ea typeface="Microsoft YaHei"/>
                 <a:cs typeface="Microsoft YaHei"/>
               </a:rPr>
-              <a:t>太 + tính từ + 了: cảm thán mức độ cao</a:t>
+              <a:t>非主谓句: câu không phân chủ-vị, hay dùng trong khẩu ngữ</a:t>
             </a:r>
           </a:p>
           <a:p>
@@ -5663,7 +5622,7 @@
                 <a:ea typeface="Microsoft YaHei"/>
                 <a:cs typeface="Microsoft YaHei"/>
               </a:rPr>
-              <a:t>太好了！</a:t>
+              <a:t>我看了一个电影。</a:t>
             </a:r>
             <a:r>
               <a:rPr sz="1500" b="0" i="1">
@@ -5674,7 +5633,7 @@
                 <a:ea typeface="Microsoft YaHei"/>
                 <a:cs typeface="Microsoft YaHei"/>
               </a:rPr>
-              <a:t>  Tài hǎo le!</a:t>
+              <a:t>  Wǒ kànle yí ge diànyǐng.</a:t>
             </a:r>
           </a:p>
           <a:p>
@@ -5692,7 +5651,7 @@
                 <a:ea typeface="Microsoft YaHei"/>
                 <a:cs typeface="Microsoft YaHei"/>
               </a:rPr>
-              <a:t>Tuyệt quá!</a:t>
+              <a:t>Mình đã xem một bộ phim.</a:t>
             </a:r>
           </a:p>
           <a:p>
@@ -5710,7 +5669,7 @@
                 <a:ea typeface="Microsoft YaHei"/>
                 <a:cs typeface="Microsoft YaHei"/>
               </a:rPr>
-              <a:t>• 非主谓句: 上课了。下雪了。— không có chủ ngữ rõ ràng, rất tự nhiên trong khẩu ngữ.</a:t>
+              <a:t>• 非主谓句: 上课了。下雪了。— tự nhiên trong khẩu ngữ, không cần chủ ngữ rõ.</a:t>
             </a:r>
           </a:p>
           <a:p>
@@ -5739,7 +5698,7 @@
                 <a:ea typeface="Microsoft YaHei"/>
                 <a:cs typeface="Microsoft YaHei"/>
               </a:rPr>
-              <a:t>了(1) phủ định: bỏ 了, thêm 没: 没下雨 (không phải 不下雨了).</a:t>
+              <a:t>Cả 2 loại 了 phủ định đều dùng 没 + BỎ 了: 没下雨 / 没看电影.</a:t>
             </a:r>
           </a:p>
         </p:txBody>
@@ -5982,7 +5941,7 @@
                 <a:ea typeface="Microsoft YaHei"/>
                 <a:cs typeface="Microsoft YaHei"/>
               </a:rPr>
-              <a:t>语法 · 第13课</a:t>
+              <a:t>语法 · đang diễn ra</a:t>
             </a:r>
           </a:p>
         </p:txBody>
@@ -6018,7 +5977,7 @@
                 <a:ea typeface="Microsoft YaHei"/>
                 <a:cs typeface="Microsoft YaHei"/>
               </a:rPr>
-              <a:t>可以 · 动词+一下 · 双宾语句</a:t>
+              <a:t>(正)在 · 太……了</a:t>
             </a:r>
           </a:p>
         </p:txBody>
@@ -6054,7 +6013,7 @@
                 <a:ea typeface="Microsoft YaHei"/>
                 <a:cs typeface="Microsoft YaHei"/>
               </a:rPr>
-              <a:t>可以: được phép / có thể</a:t>
+              <a:t>(正)在 + V (+呢): đang làm gì</a:t>
             </a:r>
           </a:p>
           <a:p>
@@ -6072,25 +6031,7 @@
                 <a:ea typeface="Microsoft YaHei"/>
                 <a:cs typeface="Microsoft YaHei"/>
               </a:rPr>
-              <a:t>动词 + 一下: làm thử/một lần, ngắn gọn, lịch sự hơn</a:t>
-            </a:r>
-          </a:p>
-          <a:p>
-            <a:pPr>
-              <a:spcBef>
-                <a:spcPts val="400"/>
-              </a:spcBef>
-            </a:pPr>
-            <a:r>
-              <a:rPr sz="2000" b="1" i="0">
-                <a:solidFill>
-                  <a:srgbClr val="1F2933"/>
-                </a:solidFill>
-                <a:latin typeface="Calibri"/>
-                <a:ea typeface="Microsoft YaHei"/>
-                <a:cs typeface="Microsoft YaHei"/>
-              </a:rPr>
-              <a:t>双宾语句: 1 động từ + 2 tân ngữ (给/问)</a:t>
+              <a:t>太 + tính từ + 了: cảm thán mức độ cao</a:t>
             </a:r>
           </a:p>
           <a:p>
@@ -6108,7 +6049,7 @@
                 <a:ea typeface="Microsoft YaHei"/>
                 <a:cs typeface="Microsoft YaHei"/>
               </a:rPr>
-              <a:t>我可以看一下吗？</a:t>
+              <a:t>他正在看电视呢。</a:t>
             </a:r>
             <a:r>
               <a:rPr sz="1500" b="0" i="1">
@@ -6119,7 +6060,7 @@
                 <a:ea typeface="Microsoft YaHei"/>
                 <a:cs typeface="Microsoft YaHei"/>
               </a:rPr>
-              <a:t>  Wǒ kěyǐ kàn yíxià ma?</a:t>
+              <a:t>  Tā zhèngzài kàn diànshì ne.</a:t>
             </a:r>
           </a:p>
           <a:p>
@@ -6137,7 +6078,7 @@
                 <a:ea typeface="Microsoft YaHei"/>
                 <a:cs typeface="Microsoft YaHei"/>
               </a:rPr>
-              <a:t>Mình xem thử một chút được không?</a:t>
+              <a:t>Anh ấy đang xem tivi.</a:t>
             </a:r>
           </a:p>
           <a:p>
@@ -6155,7 +6096,7 @@
                 <a:ea typeface="Microsoft YaHei"/>
                 <a:cs typeface="Microsoft YaHei"/>
               </a:rPr>
-              <a:t>请给我一杯茶。</a:t>
+              <a:t>太好了！</a:t>
             </a:r>
             <a:r>
               <a:rPr sz="1500" b="0" i="1">
@@ -6166,7 +6107,7 @@
                 <a:ea typeface="Microsoft YaHei"/>
                 <a:cs typeface="Microsoft YaHei"/>
               </a:rPr>
-              <a:t>  Qǐng gěi wǒ yì bēi chá.</a:t>
+              <a:t>  Tài hǎo le!</a:t>
             </a:r>
           </a:p>
           <a:p>
@@ -6184,7 +6125,7 @@
                 <a:ea typeface="Microsoft YaHei"/>
                 <a:cs typeface="Microsoft YaHei"/>
               </a:rPr>
-              <a:t>Cho tôi một cốc trà.</a:t>
+              <a:t>Tuyệt quá!</a:t>
             </a:r>
           </a:p>
           <a:p>
@@ -6202,7 +6143,7 @@
                 <a:ea typeface="Microsoft YaHei"/>
                 <a:cs typeface="Microsoft YaHei"/>
               </a:rPr>
-              <a:t>• 双宾语句: 给 + người nhận + vật (给我一杯茶 = cho TÔI một cốc TRÀ).</a:t>
+              <a:t>• 在 ở đây là PHÓ TỪ (đang diễn ra) — khác 在 giới từ chỉ nơi (nhóm vị trí ở trên), cùng chữ 2 vai trò.</a:t>
             </a:r>
           </a:p>
           <a:p>
@@ -6231,14 +6172,14 @@
                 <a:ea typeface="Microsoft YaHei"/>
                 <a:cs typeface="Microsoft YaHei"/>
               </a:rPr>
-              <a:t>一下 làm câu nhẹ nhàng/lịch sự hơn: 看一下 lịch sự hơn 看.</a:t>
+              <a:t>Phủ định 'đang làm': 没(有) + V — KHÔNG dùng 不.</a:t>
             </a:r>
           </a:p>
         </p:txBody>
       </p:sp>
       <p:pic>
         <p:nvPicPr>
-          <p:cNvPr id="7" name="Picture 6" descr="b13_keyi_yixia.jpg"/>
+          <p:cNvPr id="7" name="Picture 6" descr="b11_zhengfan_zai.jpg"/>
           <p:cNvPicPr>
             <a:picLocks noChangeAspect="1"/>
           </p:cNvPicPr>
@@ -6252,8 +6193,8 @@
         </p:blipFill>
         <p:spPr>
           <a:xfrm>
-            <a:off x="7345375" y="2554224"/>
-            <a:ext cx="4297680" cy="2865120"/>
+            <a:off x="7345375" y="2375154"/>
+            <a:ext cx="4297680" cy="3223260"/>
           </a:xfrm>
           <a:prstGeom prst="rect">
             <a:avLst/>
@@ -6474,7 +6415,7 @@
                 <a:ea typeface="Microsoft YaHei"/>
                 <a:cs typeface="Microsoft YaHei"/>
               </a:rPr>
-              <a:t>语法 · 第14课</a:t>
+              <a:t>语法 · cấu trúc từ</a:t>
             </a:r>
           </a:p>
         </p:txBody>
@@ -6510,7 +6451,7 @@
                 <a:ea typeface="Microsoft YaHei"/>
                 <a:cs typeface="Microsoft YaHei"/>
               </a:rPr>
-              <a:t>了(2) · 离合词 · 都</a:t>
+              <a:t>离合词 · 范围副词 都</a:t>
             </a:r>
           </a:p>
         </p:txBody>
@@ -6546,7 +6487,7 @@
                 <a:ea typeface="Microsoft YaHei"/>
                 <a:cs typeface="Microsoft YaHei"/>
               </a:rPr>
-              <a:t>了(2) ngay sau động từ: hành động ĐÃ xảy ra/hoàn thành</a:t>
+              <a:t>离合词: 上课/下班/说话… có thể tách ra, chèn thành phần vào giữa</a:t>
             </a:r>
           </a:p>
           <a:p>
@@ -6564,72 +6505,7 @@
                 <a:ea typeface="Microsoft YaHei"/>
                 <a:cs typeface="Microsoft YaHei"/>
               </a:rPr>
-              <a:t>离合词: 上课/下班/说话… có thể tách ra, chèn thành phần vào giữa</a:t>
-            </a:r>
-          </a:p>
-          <a:p>
-            <a:pPr>
-              <a:spcBef>
-                <a:spcPts val="400"/>
-              </a:spcBef>
-            </a:pPr>
-            <a:r>
-              <a:rPr sz="2000" b="1" i="0">
-                <a:solidFill>
-                  <a:srgbClr val="1F2933"/>
-                </a:solidFill>
-                <a:latin typeface="Calibri"/>
-                <a:ea typeface="Microsoft YaHei"/>
-                <a:cs typeface="Microsoft YaHei"/>
-              </a:rPr>
               <a:t>都: toàn bộ — đối tượng khái quát đứng TRƯỚC 都</a:t>
-            </a:r>
-          </a:p>
-          <a:p>
-            <a:pPr>
-              <a:spcBef>
-                <a:spcPts val="2000"/>
-              </a:spcBef>
-            </a:pPr>
-            <a:r>
-              <a:rPr sz="2600" b="1" i="0">
-                <a:solidFill>
-                  <a:srgbClr val="1F2933"/>
-                </a:solidFill>
-                <a:latin typeface="Calibri"/>
-                <a:ea typeface="Microsoft YaHei"/>
-                <a:cs typeface="Microsoft YaHei"/>
-              </a:rPr>
-              <a:t>我看了一个电影。</a:t>
-            </a:r>
-            <a:r>
-              <a:rPr sz="1500" b="0" i="1">
-                <a:solidFill>
-                  <a:srgbClr val="8E2B20"/>
-                </a:solidFill>
-                <a:latin typeface="Calibri"/>
-                <a:ea typeface="Microsoft YaHei"/>
-                <a:cs typeface="Microsoft YaHei"/>
-              </a:rPr>
-              <a:t>  Wǒ kànle yí ge diànyǐng.</a:t>
-            </a:r>
-          </a:p>
-          <a:p>
-            <a:pPr>
-              <a:spcBef>
-                <a:spcPts val="300"/>
-              </a:spcBef>
-            </a:pPr>
-            <a:r>
-              <a:rPr sz="1500" b="0" i="0">
-                <a:solidFill>
-                  <a:srgbClr val="6B7683"/>
-                </a:solidFill>
-                <a:latin typeface="Calibri"/>
-                <a:ea typeface="Microsoft YaHei"/>
-                <a:cs typeface="Microsoft YaHei"/>
-              </a:rPr>
-              <a:t>Mình đã xem một bộ phim.</a:t>
             </a:r>
           </a:p>
           <a:p>
@@ -6966,7 +6842,7 @@
                 <a:ea typeface="Microsoft YaHei"/>
                 <a:cs typeface="Microsoft YaHei"/>
               </a:rPr>
-              <a:t>语法 · 第15课</a:t>
+              <a:t>语法 · từ nối &amp; trợ từ</a:t>
             </a:r>
           </a:p>
         </p:txBody>
@@ -7002,7 +6878,7 @@
                 <a:ea typeface="Microsoft YaHei"/>
                 <a:cs typeface="Microsoft YaHei"/>
               </a:rPr>
-              <a:t>并列复句：……，还/也……</a:t>
+              <a:t>也 · 和 · 吧 · 呢</a:t>
             </a:r>
           </a:p>
         </p:txBody>
@@ -7016,7 +6892,7 @@
         <p:spPr>
           <a:xfrm>
             <a:off x="548640" y="1481328"/>
-            <a:ext cx="6430975" cy="5010912"/>
+            <a:ext cx="11094415" cy="5010912"/>
           </a:xfrm>
           <a:prstGeom prst="rect">
             <a:avLst/>
@@ -7038,7 +6914,61 @@
                 <a:ea typeface="Microsoft YaHei"/>
                 <a:cs typeface="Microsoft YaHei"/>
               </a:rPr>
-              <a:t>Câu ghép đẳng lập: 2 mệnh đề liên quan lô-gích, kết cấu đối xứng</a:t>
+              <a:t>也: cũng (đứng TRƯỚC động từ)</a:t>
+            </a:r>
+          </a:p>
+          <a:p>
+            <a:pPr>
+              <a:spcBef>
+                <a:spcPts val="400"/>
+              </a:spcBef>
+            </a:pPr>
+            <a:r>
+              <a:rPr sz="2000" b="1" i="0">
+                <a:solidFill>
+                  <a:srgbClr val="1F2933"/>
+                </a:solidFill>
+                <a:latin typeface="Calibri"/>
+                <a:ea typeface="Microsoft YaHei"/>
+                <a:cs typeface="Microsoft YaHei"/>
+              </a:rPr>
+              <a:t>和: và/với (nối danh từ)</a:t>
+            </a:r>
+          </a:p>
+          <a:p>
+            <a:pPr>
+              <a:spcBef>
+                <a:spcPts val="400"/>
+              </a:spcBef>
+            </a:pPr>
+            <a:r>
+              <a:rPr sz="2000" b="1" i="0">
+                <a:solidFill>
+                  <a:srgbClr val="1F2933"/>
+                </a:solidFill>
+                <a:latin typeface="Calibri"/>
+                <a:ea typeface="Microsoft YaHei"/>
+                <a:cs typeface="Microsoft YaHei"/>
+              </a:rPr>
+              <a:t>吧: đề nghị/thương lượng cuối câu</a:t>
+            </a:r>
+          </a:p>
+          <a:p>
+            <a:pPr>
+              <a:spcBef>
+                <a:spcPts val="400"/>
+              </a:spcBef>
+            </a:pPr>
+            <a:r>
+              <a:rPr sz="2000" b="1" i="0">
+                <a:solidFill>
+                  <a:srgbClr val="1F2933"/>
+                </a:solidFill>
+                <a:latin typeface="Calibri"/>
+                <a:ea typeface="Microsoft YaHei"/>
+                <a:cs typeface="Microsoft YaHei"/>
+              </a:rPr>
+              <a:t>呢: hỏi rút gọn (A呢?) / xác nhận sự việc đã biết</a:t>
             </a:r>
           </a:p>
           <a:p>
@@ -7056,7 +6986,7 @@
                 <a:ea typeface="Microsoft YaHei"/>
                 <a:cs typeface="Microsoft YaHei"/>
               </a:rPr>
-              <a:t>我们去北京，还去西安。</a:t>
+              <a:t>我也认识他，你呢？</a:t>
             </a:r>
             <a:r>
               <a:rPr sz="1500" b="0" i="1">
@@ -7067,7 +6997,7 @@
                 <a:ea typeface="Microsoft YaHei"/>
                 <a:cs typeface="Microsoft YaHei"/>
               </a:rPr>
-              <a:t>  Wǒmen qù Běijīng, hái qù Xī'ān.</a:t>
+              <a:t>  Wǒ yě rènshi tā, nǐ ne?</a:t>
             </a:r>
           </a:p>
           <a:p>
@@ -7085,7 +7015,7 @@
                 <a:ea typeface="Microsoft YaHei"/>
                 <a:cs typeface="Microsoft YaHei"/>
               </a:rPr>
-              <a:t>Chúng mình đi Bắc Kinh, còn đi cả Tây An.</a:t>
+              <a:t>Mình cũng quen anh ấy, còn bạn?</a:t>
             </a:r>
           </a:p>
           <a:p>
@@ -7103,7 +7033,7 @@
                 <a:ea typeface="Microsoft YaHei"/>
                 <a:cs typeface="Microsoft YaHei"/>
               </a:rPr>
-              <a:t>他喜欢旅游，我也喜欢。</a:t>
+              <a:t>我和你一起去吧。</a:t>
             </a:r>
             <a:r>
               <a:rPr sz="1500" b="0" i="1">
@@ -7114,7 +7044,7 @@
                 <a:ea typeface="Microsoft YaHei"/>
                 <a:cs typeface="Microsoft YaHei"/>
               </a:rPr>
-              <a:t>  Tā xǐhuan lǚyóu, wǒ yě xǐhuan.</a:t>
+              <a:t>  Wǒ hé nǐ yìqǐ qù ba.</a:t>
             </a:r>
           </a:p>
           <a:p>
@@ -7132,7 +7062,7 @@
                 <a:ea typeface="Microsoft YaHei"/>
                 <a:cs typeface="Microsoft YaHei"/>
               </a:rPr>
-              <a:t>Anh ấy thích du lịch, mình cũng thích.</a:t>
+              <a:t>Mình với bạn cùng đi nhé.</a:t>
             </a:r>
           </a:p>
           <a:p>
@@ -7150,7 +7080,7 @@
                 <a:ea typeface="Microsoft YaHei"/>
                 <a:cs typeface="Microsoft YaHei"/>
               </a:rPr>
-              <a:t>• 还/也 nối 2 vế câu có cấu trúc song song, giúp câu mạch lạc hơn.</a:t>
+              <a:t>• Trợ từ ngữ khí cuối câu: 吗(hỏi)·呢(hỏi nhẹ/xác nhận)·吧(đề nghị)·了(thay đổi) — khác nhau về sắc thái.</a:t>
             </a:r>
           </a:p>
           <a:p>
@@ -7179,7 +7109,439 @@
                 <a:ea typeface="Microsoft YaHei"/>
                 <a:cs typeface="Microsoft YaHei"/>
               </a:rPr>
-              <a:t>Đây là bài cuối cùng — câu ghép đơn giản là bước đệm chuẩn bị lên HSK2.</a:t>
+              <a:t>也/都 luôn đứng trước động từ — không đứng cuối câu như tiếng Việt 'cũng vậy'.</a:t>
+            </a:r>
+          </a:p>
+        </p:txBody>
+      </p:sp>
+      <p:pic>
+        <p:nvPicPr>
+          <p:cNvPr id="7" name="slide17.mp3">
+            <a:hlinkClick r:id="" action="ppaction://media"/>
+          </p:cNvPr>
+          <p:cNvPicPr>
+            <a:picLocks noChangeAspect="1"/>
+          </p:cNvPicPr>
+          <p:nvPr>
+            <a:videoFile r:link="rId3"/>
+            <p:extLst>
+              <p:ext uri="{DAA4B4D4-6D71-4841-9C94-3DE7FCFB9230}">
+                <p14:media xmlns:p14="http://schemas.microsoft.com/office/powerpoint/2010/main" r:embed="rId2"/>
+              </p:ext>
+            </p:extLst>
+          </p:nvPr>
+        </p:nvPicPr>
+        <p:blipFill>
+          <a:blip r:embed="rId4"/>
+          <a:stretch>
+            <a:fillRect/>
+          </a:stretch>
+        </p:blipFill>
+        <p:spPr>
+          <a:xfrm>
+            <a:off x="11076127" y="320040"/>
+            <a:ext cx="566928" cy="566928"/>
+          </a:xfrm>
+          <a:prstGeom prst="rect">
+            <a:avLst/>
+          </a:prstGeom>
+          <a:ln>
+            <a:noFill/>
+          </a:ln>
+        </p:spPr>
+      </p:pic>
+    </p:spTree>
+  </p:cSld>
+  <p:clrMapOvr>
+    <a:masterClrMapping/>
+  </p:clrMapOvr>
+  <p:timing>
+    <p:tnLst>
+      <p:par>
+        <p:cTn id="1" dur="indefinite" restart="never" nodeType="tmRoot">
+          <p:childTnLst>
+            <p:video>
+              <p:cMediaNode vol="80000">
+                <p:cTn id="2" fill="hold" display="0">
+                  <p:stCondLst>
+                    <p:cond delay="indefinite"/>
+                  </p:stCondLst>
+                </p:cTn>
+                <p:tgtEl>
+                  <p:spTgt spid="7"/>
+                </p:tgtEl>
+              </p:cMediaNode>
+            </p:video>
+          </p:childTnLst>
+        </p:cTn>
+      </p:par>
+    </p:tnLst>
+  </p:timing>
+</p:sld>
+</file>
+
+<file path=ppt/slides/slide18.xml><?xml version="1.0" encoding="utf-8"?>
+<p:sld xmlns:a="http://schemas.openxmlformats.org/drawingml/2006/main" xmlns:p="http://schemas.openxmlformats.org/presentationml/2006/main" xmlns:r="http://schemas.openxmlformats.org/officeDocument/2006/relationships">
+  <p:cSld>
+    <p:spTree>
+      <p:nvGrpSpPr>
+        <p:cNvPr id="1" name=""/>
+        <p:cNvGrpSpPr/>
+        <p:nvPr/>
+      </p:nvGrpSpPr>
+      <p:grpSpPr/>
+      <p:sp>
+        <p:nvSpPr>
+          <p:cNvPr id="2" name="Rectangle 1"/>
+          <p:cNvSpPr/>
+          <p:nvPr/>
+        </p:nvSpPr>
+        <p:spPr>
+          <a:xfrm>
+            <a:off x="0" y="0"/>
+            <a:ext cx="12191695" cy="6858000"/>
+          </a:xfrm>
+          <a:prstGeom prst="rect">
+            <a:avLst/>
+          </a:prstGeom>
+          <a:solidFill>
+            <a:srgbClr val="FFFFFF"/>
+          </a:solidFill>
+          <a:ln>
+            <a:noFill/>
+          </a:ln>
+          <a:effectLst/>
+        </p:spPr>
+        <p:style>
+          <a:lnRef idx="1">
+            <a:schemeClr val="accent1"/>
+          </a:lnRef>
+          <a:fillRef idx="3">
+            <a:schemeClr val="accent1"/>
+          </a:fillRef>
+          <a:effectRef idx="2">
+            <a:schemeClr val="accent1"/>
+          </a:effectRef>
+          <a:fontRef idx="minor">
+            <a:schemeClr val="lt1"/>
+          </a:fontRef>
+        </p:style>
+        <p:txBody>
+          <a:bodyPr rtlCol="0" anchor="ctr"/>
+          <a:lstStyle/>
+          <a:p>
+            <a:pPr algn="ctr"/>
+          </a:p>
+        </p:txBody>
+      </p:sp>
+      <p:sp>
+        <p:nvSpPr>
+          <p:cNvPr id="3" name="Rectangle 2"/>
+          <p:cNvSpPr/>
+          <p:nvPr/>
+        </p:nvSpPr>
+        <p:spPr>
+          <a:xfrm>
+            <a:off x="0" y="0"/>
+            <a:ext cx="12191695" cy="1207008"/>
+          </a:xfrm>
+          <a:prstGeom prst="rect">
+            <a:avLst/>
+          </a:prstGeom>
+          <a:solidFill>
+            <a:srgbClr val="8E2B20"/>
+          </a:solidFill>
+          <a:ln>
+            <a:noFill/>
+          </a:ln>
+          <a:effectLst/>
+        </p:spPr>
+        <p:style>
+          <a:lnRef idx="1">
+            <a:schemeClr val="accent1"/>
+          </a:lnRef>
+          <a:fillRef idx="3">
+            <a:schemeClr val="accent1"/>
+          </a:fillRef>
+          <a:effectRef idx="2">
+            <a:schemeClr val="accent1"/>
+          </a:effectRef>
+          <a:fontRef idx="minor">
+            <a:schemeClr val="lt1"/>
+          </a:fontRef>
+        </p:style>
+        <p:txBody>
+          <a:bodyPr rtlCol="0" anchor="ctr"/>
+          <a:lstStyle/>
+          <a:p>
+            <a:pPr algn="ctr"/>
+          </a:p>
+        </p:txBody>
+      </p:sp>
+      <p:sp>
+        <p:nvSpPr>
+          <p:cNvPr id="4" name="Rounded Rectangle 3"/>
+          <p:cNvSpPr/>
+          <p:nvPr/>
+        </p:nvSpPr>
+        <p:spPr>
+          <a:xfrm>
+            <a:off x="548640" y="146304"/>
+            <a:ext cx="1371600" cy="384048"/>
+          </a:xfrm>
+          <a:prstGeom prst="roundRect">
+            <a:avLst/>
+          </a:prstGeom>
+          <a:solidFill>
+            <a:srgbClr val="5F160D"/>
+          </a:solidFill>
+          <a:ln>
+            <a:noFill/>
+          </a:ln>
+          <a:effectLst/>
+        </p:spPr>
+        <p:style>
+          <a:lnRef idx="1">
+            <a:schemeClr val="accent1"/>
+          </a:lnRef>
+          <a:fillRef idx="3">
+            <a:schemeClr val="accent1"/>
+          </a:fillRef>
+          <a:effectRef idx="2">
+            <a:schemeClr val="accent1"/>
+          </a:effectRef>
+          <a:fontRef idx="minor">
+            <a:schemeClr val="lt1"/>
+          </a:fontRef>
+        </p:style>
+        <p:txBody>
+          <a:bodyPr rtlCol="0" anchor="ctr" wrap="square" tIns="25400" bIns="25400"/>
+          <a:lstStyle/>
+          <a:p>
+            <a:pPr algn="ctr"/>
+            <a:r>
+              <a:rPr sz="1600" b="1" i="0">
+                <a:solidFill>
+                  <a:srgbClr val="FFFFFF"/>
+                </a:solidFill>
+                <a:latin typeface="Calibri"/>
+                <a:ea typeface="Microsoft YaHei"/>
+                <a:cs typeface="Microsoft YaHei"/>
+              </a:rPr>
+              <a:t>语法 · câu ghép</a:t>
+            </a:r>
+          </a:p>
+        </p:txBody>
+      </p:sp>
+      <p:sp>
+        <p:nvSpPr>
+          <p:cNvPr id="5" name="TextBox 4"/>
+          <p:cNvSpPr txBox="1"/>
+          <p:nvPr/>
+        </p:nvSpPr>
+        <p:spPr>
+          <a:xfrm>
+            <a:off x="548640" y="566928"/>
+            <a:ext cx="11094415" cy="566928"/>
+          </a:xfrm>
+          <a:prstGeom prst="rect">
+            <a:avLst/>
+          </a:prstGeom>
+          <a:noFill/>
+        </p:spPr>
+        <p:txBody>
+          <a:bodyPr wrap="square" anchor="ctr">
+            <a:spAutoFit/>
+          </a:bodyPr>
+          <a:lstStyle/>
+          <a:p>
+            <a:r>
+              <a:rPr sz="2700" b="1" i="0">
+                <a:solidFill>
+                  <a:srgbClr val="FFFFFF"/>
+                </a:solidFill>
+                <a:latin typeface="Calibri"/>
+                <a:ea typeface="Microsoft YaHei"/>
+                <a:cs typeface="Microsoft YaHei"/>
+              </a:rPr>
+              <a:t>并列复句：……，还/也……</a:t>
+            </a:r>
+          </a:p>
+        </p:txBody>
+      </p:sp>
+      <p:sp>
+        <p:nvSpPr>
+          <p:cNvPr id="6" name="TextBox 5"/>
+          <p:cNvSpPr txBox="1"/>
+          <p:nvPr/>
+        </p:nvSpPr>
+        <p:spPr>
+          <a:xfrm>
+            <a:off x="548640" y="1481328"/>
+            <a:ext cx="6430975" cy="5010912"/>
+          </a:xfrm>
+          <a:prstGeom prst="rect">
+            <a:avLst/>
+          </a:prstGeom>
+          <a:noFill/>
+        </p:spPr>
+        <p:txBody>
+          <a:bodyPr wrap="square" anchor="ctr">
+            <a:spAutoFit/>
+          </a:bodyPr>
+          <a:lstStyle/>
+          <a:p>
+            <a:r>
+              <a:rPr sz="2000" b="1" i="0">
+                <a:solidFill>
+                  <a:srgbClr val="1F2933"/>
+                </a:solidFill>
+                <a:latin typeface="Calibri"/>
+                <a:ea typeface="Microsoft YaHei"/>
+                <a:cs typeface="Microsoft YaHei"/>
+              </a:rPr>
+              <a:t>Câu ghép đẳng lập: 2 mệnh đề liên quan lô-gích, kết cấu đối xứng</a:t>
+            </a:r>
+          </a:p>
+          <a:p>
+            <a:pPr>
+              <a:spcBef>
+                <a:spcPts val="2000"/>
+              </a:spcBef>
+            </a:pPr>
+            <a:r>
+              <a:rPr sz="2600" b="1" i="0">
+                <a:solidFill>
+                  <a:srgbClr val="1F2933"/>
+                </a:solidFill>
+                <a:latin typeface="Calibri"/>
+                <a:ea typeface="Microsoft YaHei"/>
+                <a:cs typeface="Microsoft YaHei"/>
+              </a:rPr>
+              <a:t>我们去北京，还去西安。</a:t>
+            </a:r>
+            <a:r>
+              <a:rPr sz="1500" b="0" i="1">
+                <a:solidFill>
+                  <a:srgbClr val="8E2B20"/>
+                </a:solidFill>
+                <a:latin typeface="Calibri"/>
+                <a:ea typeface="Microsoft YaHei"/>
+                <a:cs typeface="Microsoft YaHei"/>
+              </a:rPr>
+              <a:t>  Wǒmen qù Běijīng, hái qù Xī'ān.</a:t>
+            </a:r>
+          </a:p>
+          <a:p>
+            <a:pPr>
+              <a:spcBef>
+                <a:spcPts val="300"/>
+              </a:spcBef>
+            </a:pPr>
+            <a:r>
+              <a:rPr sz="1500" b="0" i="0">
+                <a:solidFill>
+                  <a:srgbClr val="6B7683"/>
+                </a:solidFill>
+                <a:latin typeface="Calibri"/>
+                <a:ea typeface="Microsoft YaHei"/>
+                <a:cs typeface="Microsoft YaHei"/>
+              </a:rPr>
+              <a:t>Chúng mình đi Bắc Kinh, còn đi cả Tây An.</a:t>
+            </a:r>
+          </a:p>
+          <a:p>
+            <a:pPr>
+              <a:spcBef>
+                <a:spcPts val="2000"/>
+              </a:spcBef>
+            </a:pPr>
+            <a:r>
+              <a:rPr sz="2600" b="1" i="0">
+                <a:solidFill>
+                  <a:srgbClr val="1F2933"/>
+                </a:solidFill>
+                <a:latin typeface="Calibri"/>
+                <a:ea typeface="Microsoft YaHei"/>
+                <a:cs typeface="Microsoft YaHei"/>
+              </a:rPr>
+              <a:t>他喜欢旅游，我也喜欢。</a:t>
+            </a:r>
+            <a:r>
+              <a:rPr sz="1500" b="0" i="1">
+                <a:solidFill>
+                  <a:srgbClr val="8E2B20"/>
+                </a:solidFill>
+                <a:latin typeface="Calibri"/>
+                <a:ea typeface="Microsoft YaHei"/>
+                <a:cs typeface="Microsoft YaHei"/>
+              </a:rPr>
+              <a:t>  Tā xǐhuan lǚyóu, wǒ yě xǐhuan.</a:t>
+            </a:r>
+          </a:p>
+          <a:p>
+            <a:pPr>
+              <a:spcBef>
+                <a:spcPts val="300"/>
+              </a:spcBef>
+            </a:pPr>
+            <a:r>
+              <a:rPr sz="1500" b="0" i="0">
+                <a:solidFill>
+                  <a:srgbClr val="6B7683"/>
+                </a:solidFill>
+                <a:latin typeface="Calibri"/>
+                <a:ea typeface="Microsoft YaHei"/>
+                <a:cs typeface="Microsoft YaHei"/>
+              </a:rPr>
+              <a:t>Anh ấy thích du lịch, mình cũng thích.</a:t>
+            </a:r>
+          </a:p>
+          <a:p>
+            <a:pPr>
+              <a:spcBef>
+                <a:spcPts val="1500"/>
+              </a:spcBef>
+            </a:pPr>
+            <a:r>
+              <a:rPr sz="1500" b="0" i="0">
+                <a:solidFill>
+                  <a:srgbClr val="1F2933"/>
+                </a:solidFill>
+                <a:latin typeface="Calibri"/>
+                <a:ea typeface="Microsoft YaHei"/>
+                <a:cs typeface="Microsoft YaHei"/>
+              </a:rPr>
+              <a:t>• 还/也 nối 2 vế câu có cấu trúc song song, giúp câu mạch lạc hơn.</a:t>
+            </a:r>
+          </a:p>
+          <a:p>
+            <a:pPr>
+              <a:spcBef>
+                <a:spcPts val="1400"/>
+              </a:spcBef>
+            </a:pPr>
+            <a:r>
+              <a:rPr sz="1500" b="1" i="0">
+                <a:solidFill>
+                  <a:srgbClr val="8E2B20"/>
+                </a:solidFill>
+                <a:latin typeface="Calibri"/>
+                <a:ea typeface="Microsoft YaHei"/>
+                <a:cs typeface="Microsoft YaHei"/>
+              </a:rPr>
+              <a:t>🔑 Mẹo ghi nhớ: </a:t>
+            </a:r>
+            <a:r>
+              <a:rPr sz="1500" b="0" i="0">
+                <a:solidFill>
+                  <a:srgbClr val="1F2933"/>
+                </a:solidFill>
+                <a:latin typeface="Calibri"/>
+                <a:ea typeface="Microsoft YaHei"/>
+                <a:cs typeface="Microsoft YaHei"/>
+              </a:rPr>
+              <a:t>Câu ghép đơn giản — bước đệm chuẩn bị lên HSK2.</a:t>
             </a:r>
           </a:p>
         </p:txBody>
@@ -7210,7 +7572,7 @@
       </p:pic>
       <p:pic>
         <p:nvPicPr>
-          <p:cNvPr id="8" name="slide17.mp3">
+          <p:cNvPr id="8" name="slide18.mp3">
             <a:hlinkClick r:id="" action="ppaction://media"/>
           </p:cNvPr>
           <p:cNvPicPr>
@@ -7274,7 +7636,7 @@
 </p:sld>
 </file>
 
-<file path=ppt/slides/slide18.xml><?xml version="1.0" encoding="utf-8"?>
+<file path=ppt/slides/slide19.xml><?xml version="1.0" encoding="utf-8"?>
 <p:sld xmlns:a="http://schemas.openxmlformats.org/drawingml/2006/main" xmlns:p="http://schemas.openxmlformats.org/presentationml/2006/main" xmlns:r="http://schemas.openxmlformats.org/officeDocument/2006/relationships">
   <p:cSld>
     <p:spTree>
@@ -7883,7 +8245,401 @@
 </p:sld>
 </file>
 
-<file path=ppt/slides/slide19.xml><?xml version="1.0" encoding="utf-8"?>
+<file path=ppt/slides/slide2.xml><?xml version="1.0" encoding="utf-8"?>
+<p:sld xmlns:a="http://schemas.openxmlformats.org/drawingml/2006/main" xmlns:p="http://schemas.openxmlformats.org/presentationml/2006/main" xmlns:r="http://schemas.openxmlformats.org/officeDocument/2006/relationships">
+  <p:cSld>
+    <p:spTree>
+      <p:nvGrpSpPr>
+        <p:cNvPr id="1" name=""/>
+        <p:cNvGrpSpPr/>
+        <p:nvPr/>
+      </p:nvGrpSpPr>
+      <p:grpSpPr/>
+      <p:sp>
+        <p:nvSpPr>
+          <p:cNvPr id="2" name="Rectangle 1"/>
+          <p:cNvSpPr/>
+          <p:nvPr/>
+        </p:nvSpPr>
+        <p:spPr>
+          <a:xfrm>
+            <a:off x="0" y="0"/>
+            <a:ext cx="12191695" cy="6858000"/>
+          </a:xfrm>
+          <a:prstGeom prst="rect">
+            <a:avLst/>
+          </a:prstGeom>
+          <a:solidFill>
+            <a:srgbClr val="FFFFFF"/>
+          </a:solidFill>
+          <a:ln>
+            <a:noFill/>
+          </a:ln>
+          <a:effectLst/>
+        </p:spPr>
+        <p:style>
+          <a:lnRef idx="1">
+            <a:schemeClr val="accent1"/>
+          </a:lnRef>
+          <a:fillRef idx="3">
+            <a:schemeClr val="accent1"/>
+          </a:fillRef>
+          <a:effectRef idx="2">
+            <a:schemeClr val="accent1"/>
+          </a:effectRef>
+          <a:fontRef idx="minor">
+            <a:schemeClr val="lt1"/>
+          </a:fontRef>
+        </p:style>
+        <p:txBody>
+          <a:bodyPr rtlCol="0" anchor="ctr"/>
+          <a:lstStyle/>
+          <a:p>
+            <a:pPr algn="ctr"/>
+          </a:p>
+        </p:txBody>
+      </p:sp>
+      <p:sp>
+        <p:nvSpPr>
+          <p:cNvPr id="3" name="Rectangle 2"/>
+          <p:cNvSpPr/>
+          <p:nvPr/>
+        </p:nvSpPr>
+        <p:spPr>
+          <a:xfrm>
+            <a:off x="0" y="0"/>
+            <a:ext cx="12191695" cy="1207008"/>
+          </a:xfrm>
+          <a:prstGeom prst="rect">
+            <a:avLst/>
+          </a:prstGeom>
+          <a:solidFill>
+            <a:srgbClr val="8E2B20"/>
+          </a:solidFill>
+          <a:ln>
+            <a:noFill/>
+          </a:ln>
+          <a:effectLst/>
+        </p:spPr>
+        <p:style>
+          <a:lnRef idx="1">
+            <a:schemeClr val="accent1"/>
+          </a:lnRef>
+          <a:fillRef idx="3">
+            <a:schemeClr val="accent1"/>
+          </a:fillRef>
+          <a:effectRef idx="2">
+            <a:schemeClr val="accent1"/>
+          </a:effectRef>
+          <a:fontRef idx="minor">
+            <a:schemeClr val="lt1"/>
+          </a:fontRef>
+        </p:style>
+        <p:txBody>
+          <a:bodyPr rtlCol="0" anchor="ctr"/>
+          <a:lstStyle/>
+          <a:p>
+            <a:pPr algn="ctr"/>
+          </a:p>
+        </p:txBody>
+      </p:sp>
+      <p:sp>
+        <p:nvSpPr>
+          <p:cNvPr id="4" name="Rounded Rectangle 3"/>
+          <p:cNvSpPr/>
+          <p:nvPr/>
+        </p:nvSpPr>
+        <p:spPr>
+          <a:xfrm>
+            <a:off x="548640" y="146304"/>
+            <a:ext cx="1371600" cy="384048"/>
+          </a:xfrm>
+          <a:prstGeom prst="roundRect">
+            <a:avLst/>
+          </a:prstGeom>
+          <a:solidFill>
+            <a:srgbClr val="5F160D"/>
+          </a:solidFill>
+          <a:ln>
+            <a:noFill/>
+          </a:ln>
+          <a:effectLst/>
+        </p:spPr>
+        <p:style>
+          <a:lnRef idx="1">
+            <a:schemeClr val="accent1"/>
+          </a:lnRef>
+          <a:fillRef idx="3">
+            <a:schemeClr val="accent1"/>
+          </a:fillRef>
+          <a:effectRef idx="2">
+            <a:schemeClr val="accent1"/>
+          </a:effectRef>
+          <a:fontRef idx="minor">
+            <a:schemeClr val="lt1"/>
+          </a:fontRef>
+        </p:style>
+        <p:txBody>
+          <a:bodyPr rtlCol="0" anchor="ctr" wrap="square" tIns="25400" bIns="25400"/>
+          <a:lstStyle/>
+          <a:p>
+            <a:pPr algn="ctr"/>
+            <a:r>
+              <a:rPr sz="1600" b="1" i="0">
+                <a:solidFill>
+                  <a:srgbClr val="FFFFFF"/>
+                </a:solidFill>
+                <a:latin typeface="Calibri"/>
+                <a:ea typeface="Microsoft YaHei"/>
+                <a:cs typeface="Microsoft YaHei"/>
+              </a:rPr>
+              <a:t>目标</a:t>
+            </a:r>
+          </a:p>
+        </p:txBody>
+      </p:sp>
+      <p:sp>
+        <p:nvSpPr>
+          <p:cNvPr id="5" name="TextBox 4"/>
+          <p:cNvSpPr txBox="1"/>
+          <p:nvPr/>
+        </p:nvSpPr>
+        <p:spPr>
+          <a:xfrm>
+            <a:off x="548640" y="566928"/>
+            <a:ext cx="11094415" cy="566928"/>
+          </a:xfrm>
+          <a:prstGeom prst="rect">
+            <a:avLst/>
+          </a:prstGeom>
+          <a:noFill/>
+        </p:spPr>
+        <p:txBody>
+          <a:bodyPr wrap="square" anchor="ctr">
+            <a:spAutoFit/>
+          </a:bodyPr>
+          <a:lstStyle/>
+          <a:p>
+            <a:r>
+              <a:rPr sz="2700" b="1" i="0">
+                <a:solidFill>
+                  <a:srgbClr val="FFFFFF"/>
+                </a:solidFill>
+                <a:latin typeface="Calibri"/>
+                <a:ea typeface="Microsoft YaHei"/>
+                <a:cs typeface="Microsoft YaHei"/>
+              </a:rPr>
+              <a:t>Buổi này ôn gì</a:t>
+            </a:r>
+          </a:p>
+        </p:txBody>
+      </p:sp>
+      <p:sp>
+        <p:nvSpPr>
+          <p:cNvPr id="6" name="TextBox 5"/>
+          <p:cNvSpPr txBox="1"/>
+          <p:nvPr/>
+        </p:nvSpPr>
+        <p:spPr>
+          <a:xfrm>
+            <a:off x="548640" y="1481328"/>
+            <a:ext cx="11094415" cy="5010912"/>
+          </a:xfrm>
+          <a:prstGeom prst="rect">
+            <a:avLst/>
+          </a:prstGeom>
+          <a:noFill/>
+        </p:spPr>
+        <p:txBody>
+          <a:bodyPr wrap="square" anchor="ctr">
+            <a:spAutoFit/>
+          </a:bodyPr>
+          <a:lstStyle/>
+          <a:p>
+            <a:pPr>
+              <a:spcBef>
+                <a:spcPts val="1300"/>
+              </a:spcBef>
+            </a:pPr>
+            <a:r>
+              <a:rPr sz="2000" b="1" i="0">
+                <a:solidFill>
+                  <a:srgbClr val="8E2B20"/>
+                </a:solidFill>
+                <a:latin typeface="Calibri"/>
+                <a:ea typeface="Microsoft YaHei"/>
+                <a:cs typeface="Microsoft YaHei"/>
+              </a:rPr>
+              <a:t>•  </a:t>
+            </a:r>
+            <a:r>
+              <a:rPr sz="2000" b="0" i="0">
+                <a:solidFill>
+                  <a:srgbClr val="1F2933"/>
+                </a:solidFill>
+                <a:latin typeface="Calibri"/>
+                <a:ea typeface="Microsoft YaHei"/>
+                <a:cs typeface="Microsoft YaHei"/>
+              </a:rPr>
+              <a:t>Ngữ pháp trọng tâm của 15 bài — sắp xếp lại THEO CHỦ ĐỀ, không theo thứ tự bài</a:t>
+            </a:r>
+          </a:p>
+          <a:p>
+            <a:pPr>
+              <a:spcBef>
+                <a:spcPts val="1300"/>
+              </a:spcBef>
+            </a:pPr>
+            <a:r>
+              <a:rPr sz="2000" b="1" i="0">
+                <a:solidFill>
+                  <a:srgbClr val="8E2B20"/>
+                </a:solidFill>
+                <a:latin typeface="Calibri"/>
+                <a:ea typeface="Microsoft YaHei"/>
+                <a:cs typeface="Microsoft YaHei"/>
+              </a:rPr>
+              <a:t>•  </a:t>
+            </a:r>
+            <a:r>
+              <a:rPr sz="2000" b="0" i="0">
+                <a:solidFill>
+                  <a:srgbClr val="1F2933"/>
+                </a:solidFill>
+                <a:latin typeface="Calibri"/>
+                <a:ea typeface="Microsoft YaHei"/>
+                <a:cs typeface="Microsoft YaHei"/>
+              </a:rPr>
+              <a:t>1. Câu cơ bản: xưng hô · trật tự câu · 是/的/吗 · 有/số đếm</a:t>
+            </a:r>
+          </a:p>
+          <a:p>
+            <a:pPr>
+              <a:spcBef>
+                <a:spcPts val="1300"/>
+              </a:spcBef>
+            </a:pPr>
+            <a:r>
+              <a:rPr sz="2000" b="1" i="0">
+                <a:solidFill>
+                  <a:srgbClr val="8E2B20"/>
+                </a:solidFill>
+                <a:latin typeface="Calibri"/>
+                <a:ea typeface="Microsoft YaHei"/>
+                <a:cs typeface="Microsoft YaHei"/>
+              </a:rPr>
+              <a:t>•  </a:t>
+            </a:r>
+            <a:r>
+              <a:rPr sz="2000" b="0" i="0">
+                <a:solidFill>
+                  <a:srgbClr val="1F2933"/>
+                </a:solidFill>
+                <a:latin typeface="Calibri"/>
+                <a:ea typeface="Microsoft YaHei"/>
+                <a:cs typeface="Microsoft YaHei"/>
+              </a:rPr>
+              <a:t>2. Lượng từ &amp; tiền · câu vị ngữ đặc biệt (danh từ/tính từ, không cần 是)</a:t>
+            </a:r>
+          </a:p>
+          <a:p>
+            <a:pPr>
+              <a:spcBef>
+                <a:spcPts val="1300"/>
+              </a:spcBef>
+            </a:pPr>
+            <a:r>
+              <a:rPr sz="2000" b="1" i="0">
+                <a:solidFill>
+                  <a:srgbClr val="8E2B20"/>
+                </a:solidFill>
+                <a:latin typeface="Calibri"/>
+                <a:ea typeface="Microsoft YaHei"/>
+                <a:cs typeface="Microsoft YaHei"/>
+              </a:rPr>
+              <a:t>•  </a:t>
+            </a:r>
+            <a:r>
+              <a:rPr sz="2000" b="0" i="0">
+                <a:solidFill>
+                  <a:srgbClr val="1F2933"/>
+                </a:solidFill>
+                <a:latin typeface="Calibri"/>
+                <a:ea typeface="Microsoft YaHei"/>
+                <a:cs typeface="Microsoft YaHei"/>
+              </a:rPr>
+              <a:t>3. Vị trí &amp; tồn tại · thời gian · 7 cách hỏi</a:t>
+            </a:r>
+          </a:p>
+          <a:p>
+            <a:pPr>
+              <a:spcBef>
+                <a:spcPts val="1300"/>
+              </a:spcBef>
+            </a:pPr>
+            <a:r>
+              <a:rPr sz="2000" b="1" i="0">
+                <a:solidFill>
+                  <a:srgbClr val="8E2B20"/>
+                </a:solidFill>
+                <a:latin typeface="Calibri"/>
+                <a:ea typeface="Microsoft YaHei"/>
+                <a:cs typeface="Microsoft YaHei"/>
+              </a:rPr>
+              <a:t>•  </a:t>
+            </a:r>
+            <a:r>
+              <a:rPr sz="2000" b="0" i="0">
+                <a:solidFill>
+                  <a:srgbClr val="1F2933"/>
+                </a:solidFill>
+                <a:latin typeface="Calibri"/>
+                <a:ea typeface="Microsoft YaHei"/>
+                <a:cs typeface="Microsoft YaHei"/>
+              </a:rPr>
+              <a:t>4. Năng nguyện động từ (会/想/能/要/可以) · câu nhiều động từ/tân ngữ</a:t>
+            </a:r>
+          </a:p>
+          <a:p>
+            <a:pPr>
+              <a:spcBef>
+                <a:spcPts val="1300"/>
+              </a:spcBef>
+            </a:pPr>
+            <a:r>
+              <a:rPr sz="2000" b="1" i="0">
+                <a:solidFill>
+                  <a:srgbClr val="8E2B20"/>
+                </a:solidFill>
+                <a:latin typeface="Calibri"/>
+                <a:ea typeface="Microsoft YaHei"/>
+                <a:cs typeface="Microsoft YaHei"/>
+              </a:rPr>
+              <a:t>•  </a:t>
+            </a:r>
+            <a:r>
+              <a:rPr sz="2000" b="0" i="0">
+                <a:solidFill>
+                  <a:srgbClr val="1F2933"/>
+                </a:solidFill>
+                <a:latin typeface="Calibri"/>
+                <a:ea typeface="Microsoft YaHei"/>
+                <a:cs typeface="Microsoft YaHei"/>
+              </a:rPr>
+              <a:t>5. 了(1)(2) · (正)在 · 太…了 · 离合词/都 · từ nối 也/和/吧/呢 · 并列复句</a:t>
+            </a:r>
+          </a:p>
+        </p:txBody>
+      </p:sp>
+    </p:spTree>
+  </p:cSld>
+  <p:clrMapOvr>
+    <a:masterClrMapping/>
+  </p:clrMapOvr>
+</p:sld>
+</file>
+
+<file path=ppt/slides/slide20.xml><?xml version="1.0" encoding="utf-8"?>
 <p:sld xmlns:a="http://schemas.openxmlformats.org/drawingml/2006/main" xmlns:p="http://schemas.openxmlformats.org/presentationml/2006/main" xmlns:r="http://schemas.openxmlformats.org/officeDocument/2006/relationships">
   <p:cSld>
     <p:spTree>
@@ -8492,7 +9248,7 @@
 </p:sld>
 </file>
 
-<file path=ppt/slides/slide2.xml><?xml version="1.0" encoding="utf-8"?>
+<file path=ppt/slides/slide21.xml><?xml version="1.0" encoding="utf-8"?>
 <p:sld xmlns:a="http://schemas.openxmlformats.org/drawingml/2006/main" xmlns:p="http://schemas.openxmlformats.org/presentationml/2006/main" xmlns:r="http://schemas.openxmlformats.org/officeDocument/2006/relationships">
   <p:cSld>
     <p:spTree>
@@ -8640,400 +9396,6 @@
                 <a:ea typeface="Microsoft YaHei"/>
                 <a:cs typeface="Microsoft YaHei"/>
               </a:rPr>
-              <a:t>目标</a:t>
-            </a:r>
-          </a:p>
-        </p:txBody>
-      </p:sp>
-      <p:sp>
-        <p:nvSpPr>
-          <p:cNvPr id="5" name="TextBox 4"/>
-          <p:cNvSpPr txBox="1"/>
-          <p:nvPr/>
-        </p:nvSpPr>
-        <p:spPr>
-          <a:xfrm>
-            <a:off x="548640" y="566928"/>
-            <a:ext cx="11094415" cy="566928"/>
-          </a:xfrm>
-          <a:prstGeom prst="rect">
-            <a:avLst/>
-          </a:prstGeom>
-          <a:noFill/>
-        </p:spPr>
-        <p:txBody>
-          <a:bodyPr wrap="square" anchor="ctr">
-            <a:spAutoFit/>
-          </a:bodyPr>
-          <a:lstStyle/>
-          <a:p>
-            <a:r>
-              <a:rPr sz="2700" b="1" i="0">
-                <a:solidFill>
-                  <a:srgbClr val="FFFFFF"/>
-                </a:solidFill>
-                <a:latin typeface="Calibri"/>
-                <a:ea typeface="Microsoft YaHei"/>
-                <a:cs typeface="Microsoft YaHei"/>
-              </a:rPr>
-              <a:t>Buổi này ôn gì</a:t>
-            </a:r>
-          </a:p>
-        </p:txBody>
-      </p:sp>
-      <p:sp>
-        <p:nvSpPr>
-          <p:cNvPr id="6" name="TextBox 5"/>
-          <p:cNvSpPr txBox="1"/>
-          <p:nvPr/>
-        </p:nvSpPr>
-        <p:spPr>
-          <a:xfrm>
-            <a:off x="548640" y="1481328"/>
-            <a:ext cx="11094415" cy="5010912"/>
-          </a:xfrm>
-          <a:prstGeom prst="rect">
-            <a:avLst/>
-          </a:prstGeom>
-          <a:noFill/>
-        </p:spPr>
-        <p:txBody>
-          <a:bodyPr wrap="square" anchor="ctr">
-            <a:spAutoFit/>
-          </a:bodyPr>
-          <a:lstStyle/>
-          <a:p>
-            <a:pPr>
-              <a:spcBef>
-                <a:spcPts val="1300"/>
-              </a:spcBef>
-            </a:pPr>
-            <a:r>
-              <a:rPr sz="2000" b="1" i="0">
-                <a:solidFill>
-                  <a:srgbClr val="8E2B20"/>
-                </a:solidFill>
-                <a:latin typeface="Calibri"/>
-                <a:ea typeface="Microsoft YaHei"/>
-                <a:cs typeface="Microsoft YaHei"/>
-              </a:rPr>
-              <a:t>•  </a:t>
-            </a:r>
-            <a:r>
-              <a:rPr sz="2000" b="0" i="0">
-                <a:solidFill>
-                  <a:srgbClr val="1F2933"/>
-                </a:solidFill>
-                <a:latin typeface="Calibri"/>
-                <a:ea typeface="Microsoft YaHei"/>
-                <a:cs typeface="Microsoft YaHei"/>
-              </a:rPr>
-              <a:t>Toàn bộ ngữ pháp trọng tâm của 15 bài sách New HSK Course 1 (3.0)</a:t>
-            </a:r>
-          </a:p>
-          <a:p>
-            <a:pPr>
-              <a:spcBef>
-                <a:spcPts val="1300"/>
-              </a:spcBef>
-            </a:pPr>
-            <a:r>
-              <a:rPr sz="2000" b="1" i="0">
-                <a:solidFill>
-                  <a:srgbClr val="8E2B20"/>
-                </a:solidFill>
-                <a:latin typeface="Calibri"/>
-                <a:ea typeface="Microsoft YaHei"/>
-                <a:cs typeface="Microsoft YaHei"/>
-              </a:rPr>
-              <a:t>•  </a:t>
-            </a:r>
-            <a:r>
-              <a:rPr sz="2000" b="0" i="0">
-                <a:solidFill>
-                  <a:srgbClr val="1F2933"/>
-                </a:solidFill>
-                <a:latin typeface="Calibri"/>
-                <a:ea typeface="Microsoft YaHei"/>
-                <a:cs typeface="Microsoft YaHei"/>
-              </a:rPr>
-              <a:t>~247 từ vựng cốt lõi (nhắm ~300 từ chuẩn 3.0) — xem lại ở trang học từ vựng riêng</a:t>
-            </a:r>
-          </a:p>
-          <a:p>
-            <a:pPr>
-              <a:spcBef>
-                <a:spcPts val="1300"/>
-              </a:spcBef>
-            </a:pPr>
-            <a:r>
-              <a:rPr sz="2000" b="1" i="0">
-                <a:solidFill>
-                  <a:srgbClr val="8E2B20"/>
-                </a:solidFill>
-                <a:latin typeface="Calibri"/>
-                <a:ea typeface="Microsoft YaHei"/>
-                <a:cs typeface="Microsoft YaHei"/>
-              </a:rPr>
-              <a:t>•  </a:t>
-            </a:r>
-            <a:r>
-              <a:rPr sz="2000" b="0" i="0">
-                <a:solidFill>
-                  <a:srgbClr val="1F2933"/>
-                </a:solidFill>
-                <a:latin typeface="Calibri"/>
-                <a:ea typeface="Microsoft YaHei"/>
-                <a:cs typeface="Microsoft YaHei"/>
-              </a:rPr>
-              <a:t>是/有/在 · 的 · 形容词谓语句 · 名词谓语句 · 非主谓句</a:t>
-            </a:r>
-          </a:p>
-          <a:p>
-            <a:pPr>
-              <a:spcBef>
-                <a:spcPts val="1300"/>
-              </a:spcBef>
-            </a:pPr>
-            <a:r>
-              <a:rPr sz="2000" b="1" i="0">
-                <a:solidFill>
-                  <a:srgbClr val="8E2B20"/>
-                </a:solidFill>
-                <a:latin typeface="Calibri"/>
-                <a:ea typeface="Microsoft YaHei"/>
-                <a:cs typeface="Microsoft YaHei"/>
-              </a:rPr>
-              <a:t>•  </a:t>
-            </a:r>
-            <a:r>
-              <a:rPr sz="2000" b="0" i="0">
-                <a:solidFill>
-                  <a:srgbClr val="1F2933"/>
-                </a:solidFill>
-                <a:latin typeface="Calibri"/>
-                <a:ea typeface="Microsoft YaHei"/>
-                <a:cs typeface="Microsoft YaHei"/>
-              </a:rPr>
-              <a:t>7 cách hỏi: 吗 · 呢 · 什么 · 谁 · 哪 · 几/多少 · 怎么(样) · 正反问</a:t>
-            </a:r>
-          </a:p>
-          <a:p>
-            <a:pPr>
-              <a:spcBef>
-                <a:spcPts val="1300"/>
-              </a:spcBef>
-            </a:pPr>
-            <a:r>
-              <a:rPr sz="2000" b="1" i="0">
-                <a:solidFill>
-                  <a:srgbClr val="8E2B20"/>
-                </a:solidFill>
-                <a:latin typeface="Calibri"/>
-                <a:ea typeface="Microsoft YaHei"/>
-                <a:cs typeface="Microsoft YaHei"/>
-              </a:rPr>
-              <a:t>•  </a:t>
-            </a:r>
-            <a:r>
-              <a:rPr sz="2000" b="0" i="0">
-                <a:solidFill>
-                  <a:srgbClr val="1F2933"/>
-                </a:solidFill>
-                <a:latin typeface="Calibri"/>
-                <a:ea typeface="Microsoft YaHei"/>
-                <a:cs typeface="Microsoft YaHei"/>
-              </a:rPr>
-              <a:t>能愿动词: 会 · 想 · 能 · 要 · 可以</a:t>
-            </a:r>
-          </a:p>
-          <a:p>
-            <a:pPr>
-              <a:spcBef>
-                <a:spcPts val="1300"/>
-              </a:spcBef>
-            </a:pPr>
-            <a:r>
-              <a:rPr sz="2000" b="1" i="0">
-                <a:solidFill>
-                  <a:srgbClr val="8E2B20"/>
-                </a:solidFill>
-                <a:latin typeface="Calibri"/>
-                <a:ea typeface="Microsoft YaHei"/>
-                <a:cs typeface="Microsoft YaHei"/>
-              </a:rPr>
-              <a:t>•  </a:t>
-            </a:r>
-            <a:r>
-              <a:rPr sz="2000" b="0" i="0">
-                <a:solidFill>
-                  <a:srgbClr val="1F2933"/>
-                </a:solidFill>
-                <a:latin typeface="Calibri"/>
-                <a:ea typeface="Microsoft YaHei"/>
-                <a:cs typeface="Microsoft YaHei"/>
-              </a:rPr>
-              <a:t>Cấu trúc đặc biệt: 连动句 · 存现句 · 双宾语句 · 离合词 · 并列复句</a:t>
-            </a:r>
-          </a:p>
-        </p:txBody>
-      </p:sp>
-    </p:spTree>
-  </p:cSld>
-  <p:clrMapOvr>
-    <a:masterClrMapping/>
-  </p:clrMapOvr>
-</p:sld>
-</file>
-
-<file path=ppt/slides/slide20.xml><?xml version="1.0" encoding="utf-8"?>
-<p:sld xmlns:a="http://schemas.openxmlformats.org/drawingml/2006/main" xmlns:p="http://schemas.openxmlformats.org/presentationml/2006/main" xmlns:r="http://schemas.openxmlformats.org/officeDocument/2006/relationships">
-  <p:cSld>
-    <p:spTree>
-      <p:nvGrpSpPr>
-        <p:cNvPr id="1" name=""/>
-        <p:cNvGrpSpPr/>
-        <p:nvPr/>
-      </p:nvGrpSpPr>
-      <p:grpSpPr/>
-      <p:sp>
-        <p:nvSpPr>
-          <p:cNvPr id="2" name="Rectangle 1"/>
-          <p:cNvSpPr/>
-          <p:nvPr/>
-        </p:nvSpPr>
-        <p:spPr>
-          <a:xfrm>
-            <a:off x="0" y="0"/>
-            <a:ext cx="12191695" cy="6858000"/>
-          </a:xfrm>
-          <a:prstGeom prst="rect">
-            <a:avLst/>
-          </a:prstGeom>
-          <a:solidFill>
-            <a:srgbClr val="FFFFFF"/>
-          </a:solidFill>
-          <a:ln>
-            <a:noFill/>
-          </a:ln>
-          <a:effectLst/>
-        </p:spPr>
-        <p:style>
-          <a:lnRef idx="1">
-            <a:schemeClr val="accent1"/>
-          </a:lnRef>
-          <a:fillRef idx="3">
-            <a:schemeClr val="accent1"/>
-          </a:fillRef>
-          <a:effectRef idx="2">
-            <a:schemeClr val="accent1"/>
-          </a:effectRef>
-          <a:fontRef idx="minor">
-            <a:schemeClr val="lt1"/>
-          </a:fontRef>
-        </p:style>
-        <p:txBody>
-          <a:bodyPr rtlCol="0" anchor="ctr"/>
-          <a:lstStyle/>
-          <a:p>
-            <a:pPr algn="ctr"/>
-          </a:p>
-        </p:txBody>
-      </p:sp>
-      <p:sp>
-        <p:nvSpPr>
-          <p:cNvPr id="3" name="Rectangle 2"/>
-          <p:cNvSpPr/>
-          <p:nvPr/>
-        </p:nvSpPr>
-        <p:spPr>
-          <a:xfrm>
-            <a:off x="0" y="0"/>
-            <a:ext cx="12191695" cy="1207008"/>
-          </a:xfrm>
-          <a:prstGeom prst="rect">
-            <a:avLst/>
-          </a:prstGeom>
-          <a:solidFill>
-            <a:srgbClr val="8E2B20"/>
-          </a:solidFill>
-          <a:ln>
-            <a:noFill/>
-          </a:ln>
-          <a:effectLst/>
-        </p:spPr>
-        <p:style>
-          <a:lnRef idx="1">
-            <a:schemeClr val="accent1"/>
-          </a:lnRef>
-          <a:fillRef idx="3">
-            <a:schemeClr val="accent1"/>
-          </a:fillRef>
-          <a:effectRef idx="2">
-            <a:schemeClr val="accent1"/>
-          </a:effectRef>
-          <a:fontRef idx="minor">
-            <a:schemeClr val="lt1"/>
-          </a:fontRef>
-        </p:style>
-        <p:txBody>
-          <a:bodyPr rtlCol="0" anchor="ctr"/>
-          <a:lstStyle/>
-          <a:p>
-            <a:pPr algn="ctr"/>
-          </a:p>
-        </p:txBody>
-      </p:sp>
-      <p:sp>
-        <p:nvSpPr>
-          <p:cNvPr id="4" name="Rounded Rectangle 3"/>
-          <p:cNvSpPr/>
-          <p:nvPr/>
-        </p:nvSpPr>
-        <p:spPr>
-          <a:xfrm>
-            <a:off x="548640" y="146304"/>
-            <a:ext cx="1371600" cy="384048"/>
-          </a:xfrm>
-          <a:prstGeom prst="roundRect">
-            <a:avLst/>
-          </a:prstGeom>
-          <a:solidFill>
-            <a:srgbClr val="5F160D"/>
-          </a:solidFill>
-          <a:ln>
-            <a:noFill/>
-          </a:ln>
-          <a:effectLst/>
-        </p:spPr>
-        <p:style>
-          <a:lnRef idx="1">
-            <a:schemeClr val="accent1"/>
-          </a:lnRef>
-          <a:fillRef idx="3">
-            <a:schemeClr val="accent1"/>
-          </a:fillRef>
-          <a:effectRef idx="2">
-            <a:schemeClr val="accent1"/>
-          </a:effectRef>
-          <a:fontRef idx="minor">
-            <a:schemeClr val="lt1"/>
-          </a:fontRef>
-        </p:style>
-        <p:txBody>
-          <a:bodyPr rtlCol="0" anchor="ctr" wrap="square" tIns="25400" bIns="25400"/>
-          <a:lstStyle/>
-          <a:p>
-            <a:pPr algn="ctr"/>
-            <a:r>
-              <a:rPr sz="1600" b="1" i="0">
-                <a:solidFill>
-                  <a:srgbClr val="FFFFFF"/>
-                </a:solidFill>
-                <a:latin typeface="Calibri"/>
-                <a:ea typeface="Microsoft YaHei"/>
-                <a:cs typeface="Microsoft YaHei"/>
-              </a:rPr>
               <a:t>会话</a:t>
             </a:r>
           </a:p>
@@ -9569,7 +9931,7 @@
       </p:sp>
       <p:pic>
         <p:nvPicPr>
-          <p:cNvPr id="12" name="slide20.mp3">
+          <p:cNvPr id="12" name="slide21.mp3">
             <a:hlinkClick r:id="" action="ppaction://media"/>
           </p:cNvPr>
           <p:cNvPicPr>
@@ -9633,7 +9995,7 @@
 </p:sld>
 </file>
 
-<file path=ppt/slides/slide21.xml><?xml version="1.0" encoding="utf-8"?>
+<file path=ppt/slides/slide22.xml><?xml version="1.0" encoding="utf-8"?>
 <p:sld xmlns:a="http://schemas.openxmlformats.org/drawingml/2006/main" xmlns:p="http://schemas.openxmlformats.org/presentationml/2006/main" xmlns:r="http://schemas.openxmlformats.org/officeDocument/2006/relationships">
   <p:cSld>
     <p:spTree>
@@ -9737,7 +10099,7 @@
                 <a:ea typeface="Microsoft YaHei"/>
                 <a:cs typeface="Microsoft YaHei"/>
               </a:rPr>
-              <a:t>15 bài ôn xong — chúc thi HSK1 tốt!</a:t>
+              <a:t>Ôn xong theo chủ đề — chúc thi HSK1 tốt!</a:t>
             </a:r>
           </a:p>
         </p:txBody>
@@ -9898,7 +10260,7 @@
                 <a:ea typeface="Microsoft YaHei"/>
                 <a:cs typeface="Microsoft YaHei"/>
               </a:rPr>
-              <a:t>语法 · 第1课</a:t>
+              <a:t>语法 · 基础</a:t>
             </a:r>
           </a:p>
         </p:txBody>
@@ -10372,7 +10734,7 @@
                 <a:ea typeface="Microsoft YaHei"/>
                 <a:cs typeface="Microsoft YaHei"/>
               </a:rPr>
-              <a:t>语法 · 第2课</a:t>
+              <a:t>语法 · 基础</a:t>
             </a:r>
           </a:p>
         </p:txBody>
@@ -10828,7 +11190,7 @@
                 <a:ea typeface="Microsoft YaHei"/>
                 <a:cs typeface="Microsoft YaHei"/>
               </a:rPr>
-              <a:t>语法 · 第3课</a:t>
+              <a:t>语法 · 基础</a:t>
             </a:r>
           </a:p>
         </p:txBody>
@@ -11124,7 +11486,7 @@
                 <a:ea typeface="Microsoft YaHei"/>
                 <a:cs typeface="Microsoft YaHei"/>
               </a:rPr>
-              <a:t>是 nối 2 danh từ (A là B) — không dùng để nối tính từ (xem 形容词谓语句, 第10课).</a:t>
+              <a:t>是 nối 2 danh từ (A là B) — không dùng để nối tính từ (xem nhóm câu vị ngữ đặc biệt).</a:t>
             </a:r>
           </a:p>
         </p:txBody>
@@ -11367,7 +11729,7 @@
                 <a:ea typeface="Microsoft YaHei"/>
                 <a:cs typeface="Microsoft YaHei"/>
               </a:rPr>
-              <a:t>语法 · 第4课</a:t>
+              <a:t>语法 · 基础</a:t>
             </a:r>
           </a:p>
         </p:txBody>
@@ -11403,7 +11765,7 @@
                 <a:ea typeface="Microsoft YaHei"/>
                 <a:cs typeface="Microsoft YaHei"/>
               </a:rPr>
-              <a:t>有字句 · 数字 · 量词 · 呢</a:t>
+              <a:t>有字句 · 数字 (两/二)</a:t>
             </a:r>
           </a:p>
         </p:txBody>
@@ -11463,42 +11825,6 @@
           <a:p>
             <a:pPr>
               <a:spcBef>
-                <a:spcPts val="400"/>
-              </a:spcBef>
-            </a:pPr>
-            <a:r>
-              <a:rPr sz="2000" b="1" i="0">
-                <a:solidFill>
-                  <a:srgbClr val="1F2933"/>
-                </a:solidFill>
-                <a:latin typeface="Calibri"/>
-                <a:ea typeface="Microsoft YaHei"/>
-                <a:cs typeface="Microsoft YaHei"/>
-              </a:rPr>
-              <a:t>Số + 量词 + 名词: 两个哥哥</a:t>
-            </a:r>
-          </a:p>
-          <a:p>
-            <a:pPr>
-              <a:spcBef>
-                <a:spcPts val="400"/>
-              </a:spcBef>
-            </a:pPr>
-            <a:r>
-              <a:rPr sz="2000" b="1" i="0">
-                <a:solidFill>
-                  <a:srgbClr val="1F2933"/>
-                </a:solidFill>
-                <a:latin typeface="Calibri"/>
-                <a:ea typeface="Microsoft YaHei"/>
-                <a:cs typeface="Microsoft YaHei"/>
-              </a:rPr>
-              <a:t>呢(1): hỏi rút gọn — A呢?</a:t>
-            </a:r>
-          </a:p>
-          <a:p>
-            <a:pPr>
-              <a:spcBef>
                 <a:spcPts val="2000"/>
               </a:spcBef>
             </a:pPr>
@@ -11511,7 +11837,7 @@
                 <a:ea typeface="Microsoft YaHei"/>
                 <a:cs typeface="Microsoft YaHei"/>
               </a:rPr>
-              <a:t>我有两个哥哥，你呢？</a:t>
+              <a:t>我有两个哥哥。</a:t>
             </a:r>
             <a:r>
               <a:rPr sz="1500" b="0" i="1">
@@ -11522,7 +11848,7 @@
                 <a:ea typeface="Microsoft YaHei"/>
                 <a:cs typeface="Microsoft YaHei"/>
               </a:rPr>
-              <a:t>  Wǒ yǒu liǎng ge gēge, nǐ ne?</a:t>
+              <a:t>  Wǒ yǒu liǎng ge gēge.</a:t>
             </a:r>
           </a:p>
           <a:p>
@@ -11540,7 +11866,7 @@
                 <a:ea typeface="Microsoft YaHei"/>
                 <a:cs typeface="Microsoft YaHei"/>
               </a:rPr>
-              <a:t>Mình có hai anh trai, còn bạn?</a:t>
+              <a:t>Mình có hai anh trai.</a:t>
             </a:r>
           </a:p>
           <a:p>
@@ -11877,7 +12203,7 @@
                 <a:ea typeface="Microsoft YaHei"/>
                 <a:cs typeface="Microsoft YaHei"/>
               </a:rPr>
-              <a:t>语法 · 第5课</a:t>
+              <a:t>语法 · số &amp; lượng từ</a:t>
             </a:r>
           </a:p>
         </p:txBody>
@@ -11913,7 +12239,7 @@
                 <a:ea typeface="Microsoft YaHei"/>
                 <a:cs typeface="Microsoft YaHei"/>
               </a:rPr>
-              <a:t>名词谓语句 · 能愿动词 会</a:t>
+              <a:t>量词：数 + 量 + 名 · 钱数的表达</a:t>
             </a:r>
           </a:p>
         </p:txBody>
@@ -11949,7 +12275,7 @@
                 <a:ea typeface="Microsoft YaHei"/>
                 <a:cs typeface="Microsoft YaHei"/>
               </a:rPr>
-              <a:t>名词谓语句: vị ngữ chỉ là danh từ (ngày tháng/tuổi), có thể bỏ 是</a:t>
+              <a:t>Số + lượng từ + danh từ: 三本书, 两个哥哥</a:t>
             </a:r>
           </a:p>
           <a:p>
@@ -11967,7 +12293,7 @@
                 <a:ea typeface="Microsoft YaHei"/>
                 <a:cs typeface="Microsoft YaHei"/>
               </a:rPr>
-              <a:t>会: biết làm gì (kỹ năng học được)</a:t>
+              <a:t>钱数: 元/块 — 角/毛 — 分</a:t>
             </a:r>
           </a:p>
           <a:p>
@@ -11985,7 +12311,7 @@
                 <a:ea typeface="Microsoft YaHei"/>
                 <a:cs typeface="Microsoft YaHei"/>
               </a:rPr>
-              <a:t>今天星期一。</a:t>
+              <a:t>我买了三本书。</a:t>
             </a:r>
             <a:r>
               <a:rPr sz="1500" b="0" i="1">
@@ -11996,7 +12322,7 @@
                 <a:ea typeface="Microsoft YaHei"/>
                 <a:cs typeface="Microsoft YaHei"/>
               </a:rPr>
-              <a:t>  Jīntiān xīngqīyī.</a:t>
+              <a:t>  Wǒ mǎi le sān běn shū.</a:t>
             </a:r>
           </a:p>
           <a:p>
@@ -12014,7 +12340,7 @@
                 <a:ea typeface="Microsoft YaHei"/>
                 <a:cs typeface="Microsoft YaHei"/>
               </a:rPr>
-              <a:t>Hôm nay thứ Hai.</a:t>
+              <a:t>Mình đã mua ba quyển sách.</a:t>
             </a:r>
           </a:p>
           <a:p>
@@ -12032,7 +12358,7 @@
                 <a:ea typeface="Microsoft YaHei"/>
                 <a:cs typeface="Microsoft YaHei"/>
               </a:rPr>
-              <a:t>我会做菜。</a:t>
+              <a:t>这件衣服三十五块。</a:t>
             </a:r>
             <a:r>
               <a:rPr sz="1500" b="0" i="1">
@@ -12043,7 +12369,7 @@
                 <a:ea typeface="Microsoft YaHei"/>
                 <a:cs typeface="Microsoft YaHei"/>
               </a:rPr>
-              <a:t>  Wǒ huì zuò cài.</a:t>
+              <a:t>  Zhè jiàn yīfu sānshíwǔ kuài.</a:t>
             </a:r>
           </a:p>
           <a:p>
@@ -12061,7 +12387,7 @@
                 <a:ea typeface="Microsoft YaHei"/>
                 <a:cs typeface="Microsoft YaHei"/>
               </a:rPr>
-              <a:t>Mình biết nấu ăn.</a:t>
+              <a:t>Cái áo này 35 tệ.</a:t>
             </a:r>
           </a:p>
           <a:p>
@@ -12079,7 +12405,7 @@
                 <a:ea typeface="Microsoft YaHei"/>
                 <a:cs typeface="Microsoft YaHei"/>
               </a:rPr>
-              <a:t>• 今天星期一 hoặc 今天是星期一 đều đúng — câu vị ngữ danh từ thường bỏ 是 cho gọn.</a:t>
+              <a:t>• 个(chung)·口(người nhà)·本(sách)·件(áo)·张(bàn/vé) — mỗi loại danh từ có lượng từ riêng.</a:t>
             </a:r>
           </a:p>
           <a:p>
@@ -12108,14 +12434,14 @@
                 <a:ea typeface="Microsoft YaHei"/>
                 <a:cs typeface="Microsoft YaHei"/>
               </a:rPr>
-              <a:t>会 = kỹ năng học được, khác 能 (điều kiện/khả năng, 第8课).</a:t>
+              <a:t>元 (viết) = 块 (nói) — cùng nghĩa, khác văn phong.</a:t>
             </a:r>
           </a:p>
         </p:txBody>
       </p:sp>
       <p:pic>
         <p:nvPicPr>
-          <p:cNvPr id="7" name="Picture 6" descr="b05_noun_pred_hui.jpg"/>
+          <p:cNvPr id="7" name="Picture 6" descr="b10_adj_pred_qian.jpg"/>
           <p:cNvPicPr>
             <a:picLocks noChangeAspect="1"/>
           </p:cNvPicPr>
@@ -12129,8 +12455,8 @@
         </p:blipFill>
         <p:spPr>
           <a:xfrm>
-            <a:off x="7345375" y="2375154"/>
-            <a:ext cx="4297680" cy="3223260"/>
+            <a:off x="7615123" y="1481328"/>
+            <a:ext cx="3758184" cy="5010912"/>
           </a:xfrm>
           <a:prstGeom prst="rect">
             <a:avLst/>
@@ -12351,7 +12677,7 @@
                 <a:ea typeface="Microsoft YaHei"/>
                 <a:cs typeface="Microsoft YaHei"/>
               </a:rPr>
-              <a:t>语法 · 第6课</a:t>
+              <a:t>语法 · vị ngữ đặc biệt</a:t>
             </a:r>
           </a:p>
         </p:txBody>
@@ -12387,7 +12713,7 @@
                 <a:ea typeface="Microsoft YaHei"/>
                 <a:cs typeface="Microsoft YaHei"/>
               </a:rPr>
-              <a:t>能愿动词 想 · 连动句 · 怎么</a:t>
+              <a:t>名词谓语句 · 形容词谓语句</a:t>
             </a:r>
           </a:p>
         </p:txBody>
@@ -12401,7 +12727,7 @@
         <p:spPr>
           <a:xfrm>
             <a:off x="548640" y="1481328"/>
-            <a:ext cx="6430975" cy="5010912"/>
+            <a:ext cx="11094415" cy="5010912"/>
           </a:xfrm>
           <a:prstGeom prst="rect">
             <a:avLst/>
@@ -12423,7 +12749,7 @@
                 <a:ea typeface="Microsoft YaHei"/>
                 <a:cs typeface="Microsoft YaHei"/>
               </a:rPr>
-              <a:t>想: muốn, dự định làm gì</a:t>
+              <a:t>名词谓语句: vị ngữ là danh từ (ngày tháng/tuổi), có thể bỏ 是</a:t>
             </a:r>
           </a:p>
           <a:p>
@@ -12441,25 +12767,7 @@
                 <a:ea typeface="Microsoft YaHei"/>
                 <a:cs typeface="Microsoft YaHei"/>
               </a:rPr>
-              <a:t>连动句: 2 cụm động từ nối tiếp, cùng chủ ngữ, đúng trình tự hành động</a:t>
-            </a:r>
-          </a:p>
-          <a:p>
-            <a:pPr>
-              <a:spcBef>
-                <a:spcPts val="400"/>
-              </a:spcBef>
-            </a:pPr>
-            <a:r>
-              <a:rPr sz="2000" b="1" i="0">
-                <a:solidFill>
-                  <a:srgbClr val="1F2933"/>
-                </a:solidFill>
-                <a:latin typeface="Calibri"/>
-                <a:ea typeface="Microsoft YaHei"/>
-                <a:cs typeface="Microsoft YaHei"/>
-              </a:rPr>
-              <a:t>怎么: hỏi CÁCH THỨC làm việc gì</a:t>
+              <a:t>形容词谓语句: tính từ làm vị ngữ trực tiếp, không cần 是, thường có 很/真</a:t>
             </a:r>
           </a:p>
           <a:p>
@@ -12477,7 +12785,7 @@
                 <a:ea typeface="Microsoft YaHei"/>
                 <a:cs typeface="Microsoft YaHei"/>
               </a:rPr>
-              <a:t>我想去超市买东西。</a:t>
+              <a:t>今天星期一。</a:t>
             </a:r>
             <a:r>
               <a:rPr sz="1500" b="0" i="1">
@@ -12488,7 +12796,7 @@
                 <a:ea typeface="Microsoft YaHei"/>
                 <a:cs typeface="Microsoft YaHei"/>
               </a:rPr>
-              <a:t>  Wǒ xiǎng qù chāoshì mǎi dōngxi.</a:t>
+              <a:t>  Jīntiān xīngqīyī.</a:t>
             </a:r>
           </a:p>
           <a:p>
@@ -12506,7 +12814,7 @@
                 <a:ea typeface="Microsoft YaHei"/>
                 <a:cs typeface="Microsoft YaHei"/>
               </a:rPr>
-              <a:t>Mình muốn đi siêu thị mua đồ.</a:t>
+              <a:t>Hôm nay thứ Hai.</a:t>
             </a:r>
           </a:p>
           <a:p>
@@ -12524,7 +12832,7 @@
                 <a:ea typeface="Microsoft YaHei"/>
                 <a:cs typeface="Microsoft YaHei"/>
               </a:rPr>
-              <a:t>你怎么去？</a:t>
+              <a:t>这个菜很好吃。</a:t>
             </a:r>
             <a:r>
               <a:rPr sz="1500" b="0" i="1">
@@ -12535,7 +12843,7 @@
                 <a:ea typeface="Microsoft YaHei"/>
                 <a:cs typeface="Microsoft YaHei"/>
               </a:rPr>
-              <a:t>  Nǐ zěnme qù?</a:t>
+              <a:t>  Zhège cài hěn hǎochī.</a:t>
             </a:r>
           </a:p>
           <a:p>
@@ -12553,7 +12861,7 @@
                 <a:ea typeface="Microsoft YaHei"/>
                 <a:cs typeface="Microsoft YaHei"/>
               </a:rPr>
-              <a:t>Bạn đi bằng cách nào?</a:t>
+              <a:t>Món này ngon.</a:t>
             </a:r>
           </a:p>
           <a:p>
@@ -12571,7 +12879,7 @@
                 <a:ea typeface="Microsoft YaHei"/>
                 <a:cs typeface="Microsoft YaHei"/>
               </a:rPr>
-              <a:t>• 连动句: động từ 1 (đi) trước động từ 2 (mua) — đúng thứ tự làm thật.</a:t>
+              <a:t>• 今天星期一 hoặc 今天是星期一 đều đúng — 是 có thể bỏ cho gọn.</a:t>
             </a:r>
           </a:p>
           <a:p>
@@ -12600,54 +12908,30 @@
                 <a:ea typeface="Microsoft YaHei"/>
                 <a:cs typeface="Microsoft YaHei"/>
               </a:rPr>
-              <a:t>怎么 hỏi CÁCH THỨC — khác 怎么样 hỏi TÌNH TRẠNG/Ý KIẾN (第10课).</a:t>
+              <a:t>SAI 我是好 ❌ → ĐÚNG 我很好 ✔ — tính từ vị ngữ không đi với 是.</a:t>
             </a:r>
           </a:p>
         </p:txBody>
       </p:sp>
       <p:pic>
         <p:nvPicPr>
-          <p:cNvPr id="7" name="Picture 6" descr="b06_xiang_liandong.jpg"/>
-          <p:cNvPicPr>
-            <a:picLocks noChangeAspect="1"/>
-          </p:cNvPicPr>
-          <p:nvPr/>
-        </p:nvPicPr>
-        <p:blipFill>
-          <a:blip r:embed="rId2"/>
-          <a:stretch>
-            <a:fillRect/>
-          </a:stretch>
-        </p:blipFill>
-        <p:spPr>
-          <a:xfrm>
-            <a:off x="7345375" y="2375154"/>
-            <a:ext cx="4297680" cy="3223260"/>
-          </a:xfrm>
-          <a:prstGeom prst="rect">
-            <a:avLst/>
-          </a:prstGeom>
-        </p:spPr>
-      </p:pic>
-      <p:pic>
-        <p:nvPicPr>
-          <p:cNvPr id="8" name="slide08.mp3">
+          <p:cNvPr id="7" name="slide08.mp3">
             <a:hlinkClick r:id="" action="ppaction://media"/>
           </p:cNvPr>
           <p:cNvPicPr>
             <a:picLocks noChangeAspect="1"/>
           </p:cNvPicPr>
           <p:nvPr>
-            <a:videoFile r:link="rId4"/>
+            <a:videoFile r:link="rId3"/>
             <p:extLst>
               <p:ext uri="{DAA4B4D4-6D71-4841-9C94-3DE7FCFB9230}">
-                <p14:media xmlns:p14="http://schemas.microsoft.com/office/powerpoint/2010/main" r:embed="rId3"/>
+                <p14:media xmlns:p14="http://schemas.microsoft.com/office/powerpoint/2010/main" r:embed="rId2"/>
               </p:ext>
             </p:extLst>
           </p:nvPr>
         </p:nvPicPr>
         <p:blipFill>
-          <a:blip r:embed="rId5"/>
+          <a:blip r:embed="rId4"/>
           <a:stretch>
             <a:fillRect/>
           </a:stretch>
@@ -12683,7 +12967,7 @@
                   </p:stCondLst>
                 </p:cTn>
                 <p:tgtEl>
-                  <p:spTgt spid="8"/>
+                  <p:spTgt spid="7"/>
                 </p:tgtEl>
               </p:cMediaNode>
             </p:video>
@@ -12843,7 +13127,7 @@
                 <a:ea typeface="Microsoft YaHei"/>
                 <a:cs typeface="Microsoft YaHei"/>
               </a:rPr>
-              <a:t>语法 · 第7课</a:t>
+              <a:t>语法 · vị trí &amp; tồn tại</a:t>
             </a:r>
           </a:p>
         </p:txBody>
@@ -12879,7 +13163,7 @@
                 <a:ea typeface="Microsoft YaHei"/>
                 <a:cs typeface="Microsoft YaHei"/>
               </a:rPr>
-              <a:t>点/分 · 吧 · 呢(2)</a:t>
+              <a:t>方位词 · 介词在 · 存现句 · 第</a:t>
             </a:r>
           </a:p>
         </p:txBody>
@@ -12915,7 +13199,7 @@
                 <a:ea typeface="Microsoft YaHei"/>
                 <a:cs typeface="Microsoft YaHei"/>
               </a:rPr>
-              <a:t>点/分: giờ cụ thể; 上午/下午/晚上: khoảng thời gian</a:t>
+              <a:t>方位词: 上/下/里/外/前/后</a:t>
             </a:r>
           </a:p>
           <a:p>
@@ -12933,7 +13217,7 @@
                 <a:ea typeface="Microsoft YaHei"/>
                 <a:cs typeface="Microsoft YaHei"/>
               </a:rPr>
-              <a:t>吧: đề nghị/thương lượng cuối câu</a:t>
+              <a:t>介词在 + nơi chốn: đứng TRƯỚC động từ</a:t>
             </a:r>
           </a:p>
           <a:p>
@@ -12951,7 +13235,25 @@
                 <a:ea typeface="Microsoft YaHei"/>
                 <a:cs typeface="Microsoft YaHei"/>
               </a:rPr>
-              <a:t>呢(2): xác nhận sự việc đã biết</a:t>
+              <a:t>存现句: có ai/cái gì tồn tại ở một nơi</a:t>
+            </a:r>
+          </a:p>
+          <a:p>
+            <a:pPr>
+              <a:spcBef>
+                <a:spcPts val="400"/>
+              </a:spcBef>
+            </a:pPr>
+            <a:r>
+              <a:rPr sz="2000" b="1" i="0">
+                <a:solidFill>
+                  <a:srgbClr val="1F2933"/>
+                </a:solidFill>
+                <a:latin typeface="Calibri"/>
+                <a:ea typeface="Microsoft YaHei"/>
+                <a:cs typeface="Microsoft YaHei"/>
+              </a:rPr>
+              <a:t>第 + số từ: số thứ tự</a:t>
             </a:r>
           </a:p>
           <a:p>
@@ -12969,7 +13271,7 @@
                 <a:ea typeface="Microsoft YaHei"/>
                 <a:cs typeface="Microsoft YaHei"/>
               </a:rPr>
-              <a:t>现在三点半，我们六点见吧。</a:t>
+              <a:t>猫在桌子下。</a:t>
             </a:r>
             <a:r>
               <a:rPr sz="1500" b="0" i="1">
@@ -12980,7 +13282,7 @@
                 <a:ea typeface="Microsoft YaHei"/>
                 <a:cs typeface="Microsoft YaHei"/>
               </a:rPr>
-              <a:t>  Xiànzài sān diǎn bàn, wǒmen liù diǎn jiàn ba.</a:t>
+              <a:t>  Māo zài zhuōzi xià.</a:t>
             </a:r>
           </a:p>
           <a:p>
@@ -12998,7 +13300,7 @@
                 <a:ea typeface="Microsoft YaHei"/>
                 <a:cs typeface="Microsoft YaHei"/>
               </a:rPr>
-              <a:t>Bây giờ 3 rưỡi, 6 giờ mình gặp nhau nhé.</a:t>
+              <a:t>Con mèo ở dưới bàn.</a:t>
             </a:r>
           </a:p>
           <a:p>
@@ -13016,7 +13318,7 @@
                 <a:ea typeface="Microsoft YaHei"/>
                 <a:cs typeface="Microsoft YaHei"/>
               </a:rPr>
-              <a:t>我六点半下班呢。</a:t>
+              <a:t>前边有一只狗。</a:t>
             </a:r>
             <a:r>
               <a:rPr sz="1500" b="0" i="1">
@@ -13027,7 +13329,7 @@
                 <a:ea typeface="Microsoft YaHei"/>
                 <a:cs typeface="Microsoft YaHei"/>
               </a:rPr>
-              <a:t>  Wǒ liù diǎn bàn xiàbān ne.</a:t>
+              <a:t>  Qiánbian yǒu yì zhī gǒu.</a:t>
             </a:r>
           </a:p>
           <a:p>
@@ -13045,7 +13347,54 @@
                 <a:ea typeface="Microsoft YaHei"/>
                 <a:cs typeface="Microsoft YaHei"/>
               </a:rPr>
-              <a:t>Mình 6 rưỡi mới tan làm cơ.</a:t>
+              <a:t>Đằng trước có một con chó.</a:t>
+            </a:r>
+          </a:p>
+          <a:p>
+            <a:pPr>
+              <a:spcBef>
+                <a:spcPts val="2000"/>
+              </a:spcBef>
+            </a:pPr>
+            <a:r>
+              <a:rPr sz="2600" b="1" i="0">
+                <a:solidFill>
+                  <a:srgbClr val="1F2933"/>
+                </a:solidFill>
+                <a:latin typeface="Calibri"/>
+                <a:ea typeface="Microsoft YaHei"/>
+                <a:cs typeface="Microsoft YaHei"/>
+              </a:rPr>
+              <a:t>这是我的第一个家。</a:t>
+            </a:r>
+            <a:r>
+              <a:rPr sz="1500" b="0" i="1">
+                <a:solidFill>
+                  <a:srgbClr val="8E2B20"/>
+                </a:solidFill>
+                <a:latin typeface="Calibri"/>
+                <a:ea typeface="Microsoft YaHei"/>
+                <a:cs typeface="Microsoft YaHei"/>
+              </a:rPr>
+              <a:t>  Zhè shì wǒ de dì yī ge jiā.</a:t>
+            </a:r>
+          </a:p>
+          <a:p>
+            <a:pPr>
+              <a:spcBef>
+                <a:spcPts val="300"/>
+              </a:spcBef>
+            </a:pPr>
+            <a:r>
+              <a:rPr sz="1500" b="0" i="0">
+                <a:solidFill>
+                  <a:srgbClr val="6B7683"/>
+                </a:solidFill>
+                <a:latin typeface="Calibri"/>
+                <a:ea typeface="Microsoft YaHei"/>
+                <a:cs typeface="Microsoft YaHei"/>
+              </a:rPr>
+              <a:t>Đây là ngôi nhà đầu tiên của mình.</a:t>
             </a:r>
           </a:p>
           <a:p>
@@ -13063,7 +13412,7 @@
                 <a:ea typeface="Microsoft YaHei"/>
                 <a:cs typeface="Microsoft YaHei"/>
               </a:rPr>
-              <a:t>• Từ chỉ thời gian LUÔN đứng trước động từ, giống mọi trạng ngữ khác.</a:t>
+              <a:t>• 在 giới từ (trước ĐT, chỉ nơi) khác 在 phó từ đang diễn ra (nhóm 了/在 phía sau) — cùng chữ 2 vai trò.</a:t>
             </a:r>
           </a:p>
           <a:p>
@@ -13092,14 +13441,14 @@
                 <a:ea typeface="Microsoft YaHei"/>
                 <a:cs typeface="Microsoft YaHei"/>
               </a:rPr>
-              <a:t>吧 = rủ rê/đề nghị nhẹ nhàng — khác 吗 (hỏi thật, cần trả lời có/không).</a:t>
+              <a:t>存现句 phủ định KHÔNG dùng số từ + lượng từ trước tân ngữ.</a:t>
             </a:r>
           </a:p>
         </p:txBody>
       </p:sp>
       <p:pic>
         <p:nvPicPr>
-          <p:cNvPr id="7" name="Picture 6" descr="b07_dian_fen_ba.jpg"/>
+          <p:cNvPr id="7" name="Picture 6" descr="b08_fangwei_zai_neng.jpg"/>
           <p:cNvPicPr>
             <a:picLocks noChangeAspect="1"/>
           </p:cNvPicPr>
@@ -13113,8 +13462,8 @@
         </p:blipFill>
         <p:spPr>
           <a:xfrm>
-            <a:off x="7820649" y="1481328"/>
-            <a:ext cx="3347132" cy="5010912"/>
+            <a:off x="7345375" y="2553525"/>
+            <a:ext cx="4297680" cy="2866518"/>
           </a:xfrm>
           <a:prstGeom prst="rect">
             <a:avLst/>

</xml_diff>